<commit_message>
Add EAGLE Coy to the 1st Terminator Division
</commit_message>
<xml_diff>
--- a/structure/101st-structure.pptx
+++ b/structure/101st-structure.pptx
@@ -3239,57 +3239,6 @@
       </p:sp>
       <p:sp>
         <p:nvSpPr>
-          <p:cNvPr id="6" name="Rounded Rectangle 5"/>
-          <p:cNvSpPr/>
-          <p:nvPr/>
-        </p:nvSpPr>
-        <p:spPr>
-          <a:xfrm>
-            <a:off x="932688" y="2926080"/>
-            <a:ext cx="1188720" cy="1371600"/>
-          </a:xfrm>
-          <a:prstGeom prst="roundRect">
-            <a:avLst/>
-          </a:prstGeom>
-          <a:solidFill>
-            <a:srgbClr val="2A2F36"/>
-          </a:solidFill>
-          <a:ln>
-            <a:noFill/>
-          </a:ln>
-        </p:spPr>
-        <p:style>
-          <a:lnRef idx="1">
-            <a:schemeClr val="accent1"/>
-          </a:lnRef>
-          <a:fillRef idx="3">
-            <a:schemeClr val="accent1"/>
-          </a:fillRef>
-          <a:effectRef idx="2">
-            <a:schemeClr val="accent1"/>
-          </a:effectRef>
-          <a:fontRef idx="minor">
-            <a:schemeClr val="lt1"/>
-          </a:fontRef>
-        </p:style>
-        <p:txBody>
-          <a:bodyPr rtlCol="0" anchor="ctr"/>
-          <a:lstStyle/>
-          <a:p>
-            <a:pPr algn="ctr"/>
-            <a:r>
-              <a:rPr sz="3600" b="1">
-                <a:solidFill>
-                  <a:srgbClr val="B0B8C1"/>
-                </a:solidFill>
-              </a:rPr>
-              <a:t>?</a:t>
-            </a:r>
-          </a:p>
-        </p:txBody>
-      </p:sp>
-      <p:sp>
-        <p:nvSpPr>
           <p:cNvPr id="7" name="TextBox 6"/>
           <p:cNvSpPr txBox="1"/>
           <p:nvPr/>
@@ -3314,11 +3263,11 @@
             <a:r>
               <a:rPr sz="1300" b="1">
                 <a:solidFill>
-                  <a:srgbClr val="B0B8C1"/>
+                  <a:srgbClr val="FFFFFF"/>
                 </a:solidFill>
                 <a:latin typeface="Oswald"/>
               </a:rPr>
-              <a:t>Company coming soon</a:t>
+              <a:t>EAGLE Coy</a:t>
             </a:r>
           </a:p>
         </p:txBody>
@@ -3618,6 +3567,30 @@
           </a:p>
         </p:txBody>
       </p:sp>
+      <p:pic>
+        <p:nvPicPr>
+          <p:cNvPr id="17" name="Picture 16" descr="eagle-coy-patch-transparent.png"/>
+          <p:cNvPicPr>
+            <a:picLocks noChangeAspect="1"/>
+          </p:cNvPicPr>
+          <p:nvPr/>
+        </p:nvPicPr>
+        <p:blipFill>
+          <a:blip r:embed="rId7"/>
+          <a:stretch>
+            <a:fillRect/>
+          </a:stretch>
+        </p:blipFill>
+        <p:spPr>
+          <a:xfrm>
+            <a:off x="960915" y="2926080"/>
+            <a:ext cx="1132264" cy="1371600"/>
+          </a:xfrm>
+          <a:prstGeom prst="rect">
+            <a:avLst/>
+          </a:prstGeom>
+        </p:spPr>
+      </p:pic>
     </p:spTree>
   </p:cSld>
   <p:clrMapOvr>

</xml_diff>

<commit_message>
Structure deck and PDF: four divisions
</commit_message>
<xml_diff>
--- a/structure/101st-structure.pptx
+++ b/structure/101st-structure.pptx
@@ -3113,7 +3113,7 @@
           <a:noFill/>
         </p:spPr>
         <p:txBody>
-          <a:bodyPr wrap="square" anchor="ctr" lIns="0" rIns="0" tIns="0" bIns="0">
+          <a:bodyPr wrap="square">
             <a:spAutoFit/>
           </a:bodyPr>
           <a:lstStyle/>
@@ -3148,7 +3148,7 @@
           <a:noFill/>
         </p:spPr>
         <p:txBody>
-          <a:bodyPr wrap="square" anchor="ctr" lIns="0" rIns="0" tIns="0" bIns="0">
+          <a:bodyPr wrap="square">
             <a:spAutoFit/>
           </a:bodyPr>
           <a:lstStyle/>
@@ -3161,14 +3161,14 @@
                 </a:solidFill>
                 <a:latin typeface="Oswald"/>
               </a:rPr>
-              <a:t>Three divisions, each one specialising in one enemy faction</a:t>
+              <a:t>Four divisions: one for each enemy faction, plus the Cavalry on vehicles.</a:t>
             </a:r>
           </a:p>
         </p:txBody>
       </p:sp>
       <p:pic>
         <p:nvPicPr>
-          <p:cNvPr id="4" name="Picture 3" descr="div1.png"/>
+          <p:cNvPr id="4" name="Picture 3" descr="1st-terminator-division-olive.png"/>
           <p:cNvPicPr>
             <a:picLocks noChangeAspect="1"/>
           </p:cNvPicPr>
@@ -3182,7 +3182,7 @@
         </p:blipFill>
         <p:spPr>
           <a:xfrm>
-            <a:off x="949016" y="868680"/>
+            <a:off x="564969" y="868680"/>
             <a:ext cx="1156062" cy="1371600"/>
           </a:xfrm>
           <a:prstGeom prst="rect">
@@ -3198,8 +3198,8 @@
         </p:nvSpPr>
         <p:spPr>
           <a:xfrm>
-            <a:off x="64007" y="2286000"/>
-            <a:ext cx="2926080" cy="502920"/>
+            <a:off x="40000" y="2286000"/>
+            <a:ext cx="2206000" cy="502920"/>
           </a:xfrm>
           <a:prstGeom prst="rect">
             <a:avLst/>
@@ -3207,14 +3207,14 @@
           <a:noFill/>
         </p:spPr>
         <p:txBody>
-          <a:bodyPr wrap="square" anchor="ctr" lIns="0" rIns="0" tIns="0" bIns="0">
+          <a:bodyPr wrap="square">
             <a:spAutoFit/>
           </a:bodyPr>
           <a:lstStyle/>
           <a:p>
             <a:pPr algn="ctr"/>
             <a:r>
-              <a:rPr sz="1500" b="1">
+              <a:rPr sz="1400" b="1">
                 <a:solidFill>
                   <a:srgbClr val="FF0000"/>
                 </a:solidFill>
@@ -3237,44 +3237,9 @@
           </a:p>
         </p:txBody>
       </p:sp>
-      <p:sp>
-        <p:nvSpPr>
-          <p:cNvPr id="7" name="TextBox 6"/>
-          <p:cNvSpPr txBox="1"/>
-          <p:nvPr/>
-        </p:nvSpPr>
-        <p:spPr>
-          <a:xfrm>
-            <a:off x="64007" y="4343400"/>
-            <a:ext cx="2926080" cy="274320"/>
-          </a:xfrm>
-          <a:prstGeom prst="rect">
-            <a:avLst/>
-          </a:prstGeom>
-          <a:noFill/>
-        </p:spPr>
-        <p:txBody>
-          <a:bodyPr wrap="square" anchor="ctr" lIns="0" rIns="0" tIns="0" bIns="0">
-            <a:spAutoFit/>
-          </a:bodyPr>
-          <a:lstStyle/>
-          <a:p>
-            <a:pPr algn="ctr"/>
-            <a:r>
-              <a:rPr sz="1300" b="1">
-                <a:solidFill>
-                  <a:srgbClr val="FFFFFF"/>
-                </a:solidFill>
-                <a:latin typeface="Oswald"/>
-              </a:rPr>
-              <a:t>EAGLE Coy</a:t>
-            </a:r>
-          </a:p>
-        </p:txBody>
-      </p:sp>
       <p:pic>
         <p:nvPicPr>
-          <p:cNvPr id="8" name="Picture 7" descr="div2.png"/>
+          <p:cNvPr id="6" name="Picture 5" descr="eagle-coy-olive.png"/>
           <p:cNvPicPr>
             <a:picLocks noChangeAspect="1"/>
           </p:cNvPicPr>
@@ -3288,8 +3253,8 @@
         </p:blipFill>
         <p:spPr>
           <a:xfrm>
-            <a:off x="3993968" y="868680"/>
-            <a:ext cx="1156062" cy="1371600"/>
+            <a:off x="576726" y="2926080"/>
+            <a:ext cx="1132549" cy="1371600"/>
           </a:xfrm>
           <a:prstGeom prst="rect">
             <a:avLst/>
@@ -3298,14 +3263,14 @@
       </p:pic>
       <p:sp>
         <p:nvSpPr>
-          <p:cNvPr id="9" name="TextBox 8"/>
+          <p:cNvPr id="7" name="TextBox 6"/>
           <p:cNvSpPr txBox="1"/>
           <p:nvPr/>
         </p:nvSpPr>
         <p:spPr>
           <a:xfrm>
-            <a:off x="3108960" y="2286000"/>
-            <a:ext cx="2926080" cy="502920"/>
+            <a:off x="40000" y="4343400"/>
+            <a:ext cx="2206000" cy="274320"/>
           </a:xfrm>
           <a:prstGeom prst="rect">
             <a:avLst/>
@@ -3313,39 +3278,27 @@
           <a:noFill/>
         </p:spPr>
         <p:txBody>
-          <a:bodyPr wrap="square" anchor="ctr" lIns="0" rIns="0" tIns="0" bIns="0">
+          <a:bodyPr wrap="square">
             <a:spAutoFit/>
           </a:bodyPr>
           <a:lstStyle/>
           <a:p>
             <a:pPr algn="ctr"/>
             <a:r>
-              <a:rPr sz="1500" b="1">
+              <a:rPr sz="1300" b="1">
                 <a:solidFill>
-                  <a:srgbClr val="C7D154"/>
+                  <a:srgbClr val="FFFFFF"/>
                 </a:solidFill>
                 <a:latin typeface="Oswald"/>
               </a:rPr>
-              <a:t>2nd Scorpion Division</a:t>
-            </a:r>
-          </a:p>
-          <a:p>
-            <a:pPr algn="ctr"/>
-            <a:r>
-              <a:rPr sz="1100" b="0">
-                <a:solidFill>
-                  <a:srgbClr val="B0B8C1"/>
-                </a:solidFill>
-                <a:latin typeface="Oswald"/>
-              </a:rPr>
-              <a:t>Terminid specialists</a:t>
+              <a:t>EAGLE Coy</a:t>
             </a:r>
           </a:p>
         </p:txBody>
       </p:sp>
       <p:pic>
         <p:nvPicPr>
-          <p:cNvPr id="10" name="Picture 9" descr="bear.png"/>
+          <p:cNvPr id="8" name="Picture 7" descr="2nd-scorpion-division-olive.png"/>
           <p:cNvPicPr>
             <a:picLocks noChangeAspect="1"/>
           </p:cNvPicPr>
@@ -3359,8 +3312,8 @@
         </p:blipFill>
         <p:spPr>
           <a:xfrm>
-            <a:off x="4005725" y="2926080"/>
-            <a:ext cx="1132549" cy="1371600"/>
+            <a:off x="2850969" y="868680"/>
+            <a:ext cx="1156062" cy="1371600"/>
           </a:xfrm>
           <a:prstGeom prst="rect">
             <a:avLst/>
@@ -3369,14 +3322,14 @@
       </p:pic>
       <p:sp>
         <p:nvSpPr>
-          <p:cNvPr id="11" name="TextBox 10"/>
+          <p:cNvPr id="9" name="TextBox 8"/>
           <p:cNvSpPr txBox="1"/>
           <p:nvPr/>
         </p:nvSpPr>
         <p:spPr>
           <a:xfrm>
-            <a:off x="3108960" y="4343400"/>
-            <a:ext cx="2926080" cy="274320"/>
+            <a:off x="2326000" y="2286000"/>
+            <a:ext cx="2206000" cy="502920"/>
           </a:xfrm>
           <a:prstGeom prst="rect">
             <a:avLst/>
@@ -3384,27 +3337,39 @@
           <a:noFill/>
         </p:spPr>
         <p:txBody>
-          <a:bodyPr wrap="square" anchor="ctr" lIns="0" rIns="0" tIns="0" bIns="0">
+          <a:bodyPr wrap="square">
             <a:spAutoFit/>
           </a:bodyPr>
           <a:lstStyle/>
           <a:p>
             <a:pPr algn="ctr"/>
             <a:r>
-              <a:rPr sz="1300" b="1">
+              <a:rPr sz="1400" b="1">
                 <a:solidFill>
-                  <a:srgbClr val="FFFFFF"/>
+                  <a:srgbClr val="C7D154"/>
                 </a:solidFill>
                 <a:latin typeface="Oswald"/>
               </a:rPr>
-              <a:t>BEAR Coy</a:t>
+              <a:t>2nd Scorpion Division</a:t>
+            </a:r>
+          </a:p>
+          <a:p>
+            <a:pPr algn="ctr"/>
+            <a:r>
+              <a:rPr sz="1100" b="0">
+                <a:solidFill>
+                  <a:srgbClr val="B0B8C1"/>
+                </a:solidFill>
+                <a:latin typeface="Oswald"/>
+              </a:rPr>
+              <a:t>Terminid specialists</a:t>
             </a:r>
           </a:p>
         </p:txBody>
       </p:sp>
       <p:pic>
         <p:nvPicPr>
-          <p:cNvPr id="12" name="Picture 11" descr="div3.png"/>
+          <p:cNvPr id="10" name="Picture 9" descr="bear-coy-olive.png"/>
           <p:cNvPicPr>
             <a:picLocks noChangeAspect="1"/>
           </p:cNvPicPr>
@@ -3418,8 +3383,8 @@
         </p:blipFill>
         <p:spPr>
           <a:xfrm>
-            <a:off x="7038920" y="868680"/>
-            <a:ext cx="1156062" cy="1371600"/>
+            <a:off x="2862726" y="2926080"/>
+            <a:ext cx="1132549" cy="1371600"/>
           </a:xfrm>
           <a:prstGeom prst="rect">
             <a:avLst/>
@@ -3428,14 +3393,14 @@
       </p:pic>
       <p:sp>
         <p:nvSpPr>
-          <p:cNvPr id="13" name="TextBox 12"/>
+          <p:cNvPr id="11" name="TextBox 10"/>
           <p:cNvSpPr txBox="1"/>
           <p:nvPr/>
         </p:nvSpPr>
         <p:spPr>
           <a:xfrm>
-            <a:off x="6153912" y="2286000"/>
-            <a:ext cx="2926080" cy="502920"/>
+            <a:off x="2326000" y="4343400"/>
+            <a:ext cx="2206000" cy="274320"/>
           </a:xfrm>
           <a:prstGeom prst="rect">
             <a:avLst/>
@@ -3443,39 +3408,27 @@
           <a:noFill/>
         </p:spPr>
         <p:txBody>
-          <a:bodyPr wrap="square" anchor="ctr" lIns="0" rIns="0" tIns="0" bIns="0">
+          <a:bodyPr wrap="square">
             <a:spAutoFit/>
           </a:bodyPr>
           <a:lstStyle/>
           <a:p>
             <a:pPr algn="ctr"/>
             <a:r>
-              <a:rPr sz="1500" b="1">
+              <a:rPr sz="1300" b="1">
                 <a:solidFill>
-                  <a:srgbClr val="A65CE6"/>
+                  <a:srgbClr val="FFFFFF"/>
                 </a:solidFill>
                 <a:latin typeface="Oswald"/>
               </a:rPr>
-              <a:t>3rd Kraken Division</a:t>
-            </a:r>
-          </a:p>
-          <a:p>
-            <a:pPr algn="ctr"/>
-            <a:r>
-              <a:rPr sz="1100" b="0">
-                <a:solidFill>
-                  <a:srgbClr val="B0B8C1"/>
-                </a:solidFill>
-                <a:latin typeface="Oswald"/>
-              </a:rPr>
-              <a:t>Illuminate specialists</a:t>
+              <a:t>BEAR Coy</a:t>
             </a:r>
           </a:p>
         </p:txBody>
       </p:sp>
       <p:pic>
         <p:nvPicPr>
-          <p:cNvPr id="14" name="Picture 13" descr="fox.png"/>
+          <p:cNvPr id="12" name="Picture 11" descr="3rd-kraken-division-olive.png"/>
           <p:cNvPicPr>
             <a:picLocks noChangeAspect="1"/>
           </p:cNvPicPr>
@@ -3489,8 +3442,8 @@
         </p:blipFill>
         <p:spPr>
           <a:xfrm>
-            <a:off x="7050677" y="2926080"/>
-            <a:ext cx="1132549" cy="1371600"/>
+            <a:off x="5136969" y="868680"/>
+            <a:ext cx="1156062" cy="1371600"/>
           </a:xfrm>
           <a:prstGeom prst="rect">
             <a:avLst/>
@@ -3499,14 +3452,14 @@
       </p:pic>
       <p:sp>
         <p:nvSpPr>
-          <p:cNvPr id="15" name="TextBox 14"/>
+          <p:cNvPr id="13" name="TextBox 12"/>
           <p:cNvSpPr txBox="1"/>
           <p:nvPr/>
         </p:nvSpPr>
         <p:spPr>
           <a:xfrm>
-            <a:off x="6153912" y="4343400"/>
-            <a:ext cx="2926080" cy="274320"/>
+            <a:off x="4612000" y="2286000"/>
+            <a:ext cx="2206000" cy="502920"/>
           </a:xfrm>
           <a:prstGeom prst="rect">
             <a:avLst/>
@@ -3514,45 +3467,22 @@
           <a:noFill/>
         </p:spPr>
         <p:txBody>
-          <a:bodyPr wrap="square" anchor="ctr" lIns="0" rIns="0" tIns="0" bIns="0">
+          <a:bodyPr wrap="square">
             <a:spAutoFit/>
           </a:bodyPr>
           <a:lstStyle/>
           <a:p>
             <a:pPr algn="ctr"/>
             <a:r>
-              <a:rPr sz="1300" b="1">
+              <a:rPr sz="1400" b="1">
                 <a:solidFill>
-                  <a:srgbClr val="FFFFFF"/>
+                  <a:srgbClr val="A65CE6"/>
                 </a:solidFill>
                 <a:latin typeface="Oswald"/>
               </a:rPr>
-              <a:t>FOX Coy</a:t>
-            </a:r>
-          </a:p>
-        </p:txBody>
-      </p:sp>
-      <p:sp>
-        <p:nvSpPr>
-          <p:cNvPr id="16" name="TextBox 15"/>
-          <p:cNvSpPr txBox="1"/>
-          <p:nvPr/>
-        </p:nvSpPr>
-        <p:spPr>
-          <a:xfrm>
-            <a:off x="0" y="4709160"/>
-            <a:ext cx="9144000" cy="274320"/>
-          </a:xfrm>
-          <a:prstGeom prst="rect">
-            <a:avLst/>
-          </a:prstGeom>
-          <a:noFill/>
-        </p:spPr>
-        <p:txBody>
-          <a:bodyPr wrap="square" anchor="ctr" lIns="0" rIns="0" tIns="0" bIns="0">
-            <a:spAutoFit/>
-          </a:bodyPr>
-          <a:lstStyle/>
+              <a:t>3rd Kraken Division</a:t>
+            </a:r>
+          </a:p>
           <a:p>
             <a:pPr algn="ctr"/>
             <a:r>
@@ -3562,14 +3492,14 @@
                 </a:solidFill>
                 <a:latin typeface="Oswald"/>
               </a:rPr>
-              <a:t>Your patch colour tells you which front you fight on.</a:t>
+              <a:t>Illuminate specialists</a:t>
             </a:r>
           </a:p>
         </p:txBody>
       </p:sp>
       <p:pic>
         <p:nvPicPr>
-          <p:cNvPr id="17" name="Picture 16" descr="eagle-coy-patch-transparent.png"/>
+          <p:cNvPr id="14" name="Picture 13" descr="fox-coy-olive.png"/>
           <p:cNvPicPr>
             <a:picLocks noChangeAspect="1"/>
           </p:cNvPicPr>
@@ -3583,14 +3513,214 @@
         </p:blipFill>
         <p:spPr>
           <a:xfrm>
-            <a:off x="960915" y="2926080"/>
-            <a:ext cx="1132264" cy="1371600"/>
+            <a:off x="5148726" y="2926080"/>
+            <a:ext cx="1132549" cy="1371600"/>
           </a:xfrm>
           <a:prstGeom prst="rect">
             <a:avLst/>
           </a:prstGeom>
         </p:spPr>
       </p:pic>
+      <p:sp>
+        <p:nvSpPr>
+          <p:cNvPr id="15" name="TextBox 14"/>
+          <p:cNvSpPr txBox="1"/>
+          <p:nvPr/>
+        </p:nvSpPr>
+        <p:spPr>
+          <a:xfrm>
+            <a:off x="4612000" y="4343400"/>
+            <a:ext cx="2206000" cy="274320"/>
+          </a:xfrm>
+          <a:prstGeom prst="rect">
+            <a:avLst/>
+          </a:prstGeom>
+          <a:noFill/>
+        </p:spPr>
+        <p:txBody>
+          <a:bodyPr wrap="square">
+            <a:spAutoFit/>
+          </a:bodyPr>
+          <a:lstStyle/>
+          <a:p>
+            <a:pPr algn="ctr"/>
+            <a:r>
+              <a:rPr sz="1300" b="1">
+                <a:solidFill>
+                  <a:srgbClr val="FFFFFF"/>
+                </a:solidFill>
+                <a:latin typeface="Oswald"/>
+              </a:rPr>
+              <a:t>FOX Coy</a:t>
+            </a:r>
+          </a:p>
+        </p:txBody>
+      </p:sp>
+      <p:pic>
+        <p:nvPicPr>
+          <p:cNvPr id="16" name="Picture 15" descr="4th-cavalry-division-final.png"/>
+          <p:cNvPicPr>
+            <a:picLocks noChangeAspect="1"/>
+          </p:cNvPicPr>
+          <p:nvPr/>
+        </p:nvPicPr>
+        <p:blipFill>
+          <a:blip r:embed="rId8"/>
+          <a:stretch>
+            <a:fillRect/>
+          </a:stretch>
+        </p:blipFill>
+        <p:spPr>
+          <a:xfrm>
+            <a:off x="7422969" y="868680"/>
+            <a:ext cx="1156062" cy="1371600"/>
+          </a:xfrm>
+          <a:prstGeom prst="rect">
+            <a:avLst/>
+          </a:prstGeom>
+        </p:spPr>
+      </p:pic>
+      <p:sp>
+        <p:nvSpPr>
+          <p:cNvPr id="17" name="TextBox 16"/>
+          <p:cNvSpPr txBox="1"/>
+          <p:nvPr/>
+        </p:nvSpPr>
+        <p:spPr>
+          <a:xfrm>
+            <a:off x="6898000" y="2286000"/>
+            <a:ext cx="2206000" cy="502920"/>
+          </a:xfrm>
+          <a:prstGeom prst="rect">
+            <a:avLst/>
+          </a:prstGeom>
+          <a:noFill/>
+        </p:spPr>
+        <p:txBody>
+          <a:bodyPr wrap="square">
+            <a:spAutoFit/>
+          </a:bodyPr>
+          <a:lstStyle/>
+          <a:p>
+            <a:pPr algn="ctr"/>
+            <a:r>
+              <a:rPr sz="1400" b="1">
+                <a:solidFill>
+                  <a:srgbClr val="60A040"/>
+                </a:solidFill>
+                <a:latin typeface="Oswald"/>
+              </a:rPr>
+              <a:t>4th Cavalry Division</a:t>
+            </a:r>
+          </a:p>
+          <a:p>
+            <a:pPr algn="ctr"/>
+            <a:r>
+              <a:rPr sz="1100" b="0">
+                <a:solidFill>
+                  <a:srgbClr val="B0B8C1"/>
+                </a:solidFill>
+                <a:latin typeface="Oswald"/>
+              </a:rPr>
+              <a:t>Vehicle specialists</a:t>
+            </a:r>
+          </a:p>
+        </p:txBody>
+      </p:sp>
+      <p:pic>
+        <p:nvPicPr>
+          <p:cNvPr id="18" name="Picture 17" descr="bronco-coy-olive.png"/>
+          <p:cNvPicPr>
+            <a:picLocks noChangeAspect="1"/>
+          </p:cNvPicPr>
+          <p:nvPr/>
+        </p:nvPicPr>
+        <p:blipFill>
+          <a:blip r:embed="rId9"/>
+          <a:stretch>
+            <a:fillRect/>
+          </a:stretch>
+        </p:blipFill>
+        <p:spPr>
+          <a:xfrm>
+            <a:off x="7433746" y="2926080"/>
+            <a:ext cx="1134509" cy="1371600"/>
+          </a:xfrm>
+          <a:prstGeom prst="rect">
+            <a:avLst/>
+          </a:prstGeom>
+        </p:spPr>
+      </p:pic>
+      <p:sp>
+        <p:nvSpPr>
+          <p:cNvPr id="19" name="TextBox 18"/>
+          <p:cNvSpPr txBox="1"/>
+          <p:nvPr/>
+        </p:nvSpPr>
+        <p:spPr>
+          <a:xfrm>
+            <a:off x="6898000" y="4343400"/>
+            <a:ext cx="2206000" cy="274320"/>
+          </a:xfrm>
+          <a:prstGeom prst="rect">
+            <a:avLst/>
+          </a:prstGeom>
+          <a:noFill/>
+        </p:spPr>
+        <p:txBody>
+          <a:bodyPr wrap="square">
+            <a:spAutoFit/>
+          </a:bodyPr>
+          <a:lstStyle/>
+          <a:p>
+            <a:pPr algn="ctr"/>
+            <a:r>
+              <a:rPr sz="1300" b="1">
+                <a:solidFill>
+                  <a:srgbClr val="FFFFFF"/>
+                </a:solidFill>
+                <a:latin typeface="Oswald"/>
+              </a:rPr>
+              <a:t>BRONCO Coy</a:t>
+            </a:r>
+          </a:p>
+        </p:txBody>
+      </p:sp>
+      <p:sp>
+        <p:nvSpPr>
+          <p:cNvPr id="20" name="TextBox 19"/>
+          <p:cNvSpPr txBox="1"/>
+          <p:nvPr/>
+        </p:nvSpPr>
+        <p:spPr>
+          <a:xfrm>
+            <a:off x="0" y="4709160"/>
+            <a:ext cx="9144000" cy="274320"/>
+          </a:xfrm>
+          <a:prstGeom prst="rect">
+            <a:avLst/>
+          </a:prstGeom>
+          <a:noFill/>
+        </p:spPr>
+        <p:txBody>
+          <a:bodyPr wrap="square">
+            <a:spAutoFit/>
+          </a:bodyPr>
+          <a:lstStyle/>
+          <a:p>
+            <a:pPr algn="ctr"/>
+            <a:r>
+              <a:rPr sz="1100" b="0">
+                <a:solidFill>
+                  <a:srgbClr val="B0B8C1"/>
+                </a:solidFill>
+                <a:latin typeface="Oswald"/>
+              </a:rPr>
+              <a:t>Your division colour tells you where you fight.</a:t>
+            </a:r>
+          </a:p>
+        </p:txBody>
+      </p:sp>
     </p:spTree>
   </p:cSld>
   <p:clrMapOvr>

</xml_diff>

<commit_message>
Rebrand to 101st Commando Battalion: new logo and olive palette, PLT patches, v2 chart, remove Propaganda section
</commit_message>
<xml_diff>
--- a/structure/101st-structure.pptx
+++ b/structure/101st-structure.pptx
@@ -3126,49 +3126,14 @@
                 </a:solidFill>
                 <a:latin typeface="Oswald"/>
               </a:rPr>
-              <a:t>THE 101st</a:t>
-            </a:r>
-          </a:p>
-        </p:txBody>
-      </p:sp>
-      <p:sp>
-        <p:nvSpPr>
-          <p:cNvPr id="3" name="TextBox 2"/>
-          <p:cNvSpPr txBox="1"/>
-          <p:nvPr/>
-        </p:nvSpPr>
-        <p:spPr>
-          <a:xfrm>
-            <a:off x="0" y="475488"/>
-            <a:ext cx="9144000" cy="274320"/>
-          </a:xfrm>
-          <a:prstGeom prst="rect">
-            <a:avLst/>
-          </a:prstGeom>
-          <a:noFill/>
-        </p:spPr>
-        <p:txBody>
-          <a:bodyPr wrap="square">
-            <a:spAutoFit/>
-          </a:bodyPr>
-          <a:lstStyle/>
-          <a:p>
-            <a:pPr algn="ctr"/>
-            <a:r>
-              <a:rPr sz="1200" b="0">
-                <a:solidFill>
-                  <a:srgbClr val="B0B8C1"/>
-                </a:solidFill>
-                <a:latin typeface="Oswald"/>
-              </a:rPr>
-              <a:t>Four divisions: one for each enemy faction, plus the Cavalry on vehicles.</a:t>
+              <a:t>101st COMMANDO BATTALION</a:t>
             </a:r>
           </a:p>
         </p:txBody>
       </p:sp>
       <p:pic>
         <p:nvPicPr>
-          <p:cNvPr id="4" name="Picture 3" descr="1st-terminator-division-olive.png"/>
+          <p:cNvPr id="3" name="Picture 2" descr="101st-commando-logo.png"/>
           <p:cNvPicPr>
             <a:picLocks noChangeAspect="1"/>
           </p:cNvPicPr>
@@ -3182,14 +3147,38 @@
         </p:blipFill>
         <p:spPr>
           <a:xfrm>
-            <a:off x="564969" y="868680"/>
-            <a:ext cx="1156062" cy="1371600"/>
+            <a:off x="228600" y="73152"/>
+            <a:ext cx="731520" cy="731520"/>
           </a:xfrm>
           <a:prstGeom prst="rect">
             <a:avLst/>
           </a:prstGeom>
         </p:spPr>
       </p:pic>
+      <p:pic>
+        <p:nvPicPr>
+          <p:cNvPr id="4" name="Picture 3" descr="101st-commando-logo.png"/>
+          <p:cNvPicPr>
+            <a:picLocks noChangeAspect="1"/>
+          </p:cNvPicPr>
+          <p:nvPr/>
+        </p:nvPicPr>
+        <p:blipFill>
+          <a:blip r:embed="rId2"/>
+          <a:stretch>
+            <a:fillRect/>
+          </a:stretch>
+        </p:blipFill>
+        <p:spPr>
+          <a:xfrm>
+            <a:off x="8183880" y="73152"/>
+            <a:ext cx="731520" cy="731520"/>
+          </a:xfrm>
+          <a:prstGeom prst="rect">
+            <a:avLst/>
+          </a:prstGeom>
+        </p:spPr>
+      </p:pic>
       <p:sp>
         <p:nvSpPr>
           <p:cNvPr id="5" name="TextBox 4"/>
@@ -3198,8 +3187,8 @@
         </p:nvSpPr>
         <p:spPr>
           <a:xfrm>
-            <a:off x="40000" y="2286000"/>
-            <a:ext cx="2206000" cy="502920"/>
+            <a:off x="0" y="475488"/>
+            <a:ext cx="9144000" cy="274320"/>
           </a:xfrm>
           <a:prstGeom prst="rect">
             <a:avLst/>
@@ -3214,32 +3203,20 @@
           <a:p>
             <a:pPr algn="ctr"/>
             <a:r>
-              <a:rPr sz="1400" b="1">
-                <a:solidFill>
-                  <a:srgbClr val="FF0000"/>
-                </a:solidFill>
-                <a:latin typeface="Oswald"/>
-              </a:rPr>
-              <a:t>1st Terminator Division</a:t>
-            </a:r>
-          </a:p>
-          <a:p>
-            <a:pPr algn="ctr"/>
-            <a:r>
-              <a:rPr sz="1100" b="0">
+              <a:rPr sz="1200" b="0">
                 <a:solidFill>
                   <a:srgbClr val="B0B8C1"/>
                 </a:solidFill>
                 <a:latin typeface="Oswald"/>
               </a:rPr>
-              <a:t>Automaton specialists</a:t>
+              <a:t>Four divisions: one for each enemy faction, plus the Cavalry on vehicles.</a:t>
             </a:r>
           </a:p>
         </p:txBody>
       </p:sp>
       <p:pic>
         <p:nvPicPr>
-          <p:cNvPr id="6" name="Picture 5" descr="eagle-coy-olive.png"/>
+          <p:cNvPr id="6" name="Picture 5" descr="1st-terminator-division-olive.png"/>
           <p:cNvPicPr>
             <a:picLocks noChangeAspect="1"/>
           </p:cNvPicPr>
@@ -3253,8 +3230,8 @@
         </p:blipFill>
         <p:spPr>
           <a:xfrm>
-            <a:off x="576726" y="2926080"/>
-            <a:ext cx="1132549" cy="1371600"/>
+            <a:off x="564969" y="868680"/>
+            <a:ext cx="1156062" cy="1371600"/>
           </a:xfrm>
           <a:prstGeom prst="rect">
             <a:avLst/>
@@ -3269,8 +3246,8 @@
         </p:nvSpPr>
         <p:spPr>
           <a:xfrm>
-            <a:off x="40000" y="4343400"/>
-            <a:ext cx="2206000" cy="274320"/>
+            <a:off x="40000" y="2286000"/>
+            <a:ext cx="2206000" cy="502920"/>
           </a:xfrm>
           <a:prstGeom prst="rect">
             <a:avLst/>
@@ -3285,20 +3262,32 @@
           <a:p>
             <a:pPr algn="ctr"/>
             <a:r>
-              <a:rPr sz="1300" b="1">
+              <a:rPr sz="1400" b="1">
                 <a:solidFill>
-                  <a:srgbClr val="FFFFFF"/>
+                  <a:srgbClr val="FF0000"/>
                 </a:solidFill>
                 <a:latin typeface="Oswald"/>
               </a:rPr>
-              <a:t>EAGLE Coy</a:t>
+              <a:t>1st Terminator Division</a:t>
+            </a:r>
+          </a:p>
+          <a:p>
+            <a:pPr algn="ctr"/>
+            <a:r>
+              <a:rPr sz="1100" b="0">
+                <a:solidFill>
+                  <a:srgbClr val="B0B8C1"/>
+                </a:solidFill>
+                <a:latin typeface="Oswald"/>
+              </a:rPr>
+              <a:t>Automaton specialists</a:t>
             </a:r>
           </a:p>
         </p:txBody>
       </p:sp>
       <p:pic>
         <p:nvPicPr>
-          <p:cNvPr id="8" name="Picture 7" descr="2nd-scorpion-division-olive.png"/>
+          <p:cNvPr id="8" name="Picture 7" descr="eagle-plt-olive.png"/>
           <p:cNvPicPr>
             <a:picLocks noChangeAspect="1"/>
           </p:cNvPicPr>
@@ -3312,8 +3301,8 @@
         </p:blipFill>
         <p:spPr>
           <a:xfrm>
-            <a:off x="2850969" y="868680"/>
-            <a:ext cx="1156062" cy="1371600"/>
+            <a:off x="576726" y="2926080"/>
+            <a:ext cx="1132549" cy="1371600"/>
           </a:xfrm>
           <a:prstGeom prst="rect">
             <a:avLst/>
@@ -3328,8 +3317,8 @@
         </p:nvSpPr>
         <p:spPr>
           <a:xfrm>
-            <a:off x="2326000" y="2286000"/>
-            <a:ext cx="2206000" cy="502920"/>
+            <a:off x="40000" y="4343400"/>
+            <a:ext cx="2206000" cy="274320"/>
           </a:xfrm>
           <a:prstGeom prst="rect">
             <a:avLst/>
@@ -3344,32 +3333,20 @@
           <a:p>
             <a:pPr algn="ctr"/>
             <a:r>
-              <a:rPr sz="1400" b="1">
+              <a:rPr sz="1300" b="1">
                 <a:solidFill>
-                  <a:srgbClr val="C7D154"/>
+                  <a:srgbClr val="FFFFFF"/>
                 </a:solidFill>
                 <a:latin typeface="Oswald"/>
               </a:rPr>
-              <a:t>2nd Scorpion Division</a:t>
-            </a:r>
-          </a:p>
-          <a:p>
-            <a:pPr algn="ctr"/>
-            <a:r>
-              <a:rPr sz="1100" b="0">
-                <a:solidFill>
-                  <a:srgbClr val="B0B8C1"/>
-                </a:solidFill>
-                <a:latin typeface="Oswald"/>
-              </a:rPr>
-              <a:t>Terminid specialists</a:t>
+              <a:t>EAGLE PLT</a:t>
             </a:r>
           </a:p>
         </p:txBody>
       </p:sp>
       <p:pic>
         <p:nvPicPr>
-          <p:cNvPr id="10" name="Picture 9" descr="bear-coy-olive.png"/>
+          <p:cNvPr id="10" name="Picture 9" descr="2nd-scorpion-division-olive.png"/>
           <p:cNvPicPr>
             <a:picLocks noChangeAspect="1"/>
           </p:cNvPicPr>
@@ -3383,8 +3360,8 @@
         </p:blipFill>
         <p:spPr>
           <a:xfrm>
-            <a:off x="2862726" y="2926080"/>
-            <a:ext cx="1132549" cy="1371600"/>
+            <a:off x="2850969" y="868680"/>
+            <a:ext cx="1156062" cy="1371600"/>
           </a:xfrm>
           <a:prstGeom prst="rect">
             <a:avLst/>
@@ -3399,8 +3376,8 @@
         </p:nvSpPr>
         <p:spPr>
           <a:xfrm>
-            <a:off x="2326000" y="4343400"/>
-            <a:ext cx="2206000" cy="274320"/>
+            <a:off x="2326000" y="2286000"/>
+            <a:ext cx="2206000" cy="502920"/>
           </a:xfrm>
           <a:prstGeom prst="rect">
             <a:avLst/>
@@ -3415,20 +3392,32 @@
           <a:p>
             <a:pPr algn="ctr"/>
             <a:r>
-              <a:rPr sz="1300" b="1">
+              <a:rPr sz="1400" b="1">
                 <a:solidFill>
-                  <a:srgbClr val="FFFFFF"/>
+                  <a:srgbClr val="C7D154"/>
                 </a:solidFill>
                 <a:latin typeface="Oswald"/>
               </a:rPr>
-              <a:t>BEAR Coy</a:t>
+              <a:t>2nd Scorpion Division</a:t>
+            </a:r>
+          </a:p>
+          <a:p>
+            <a:pPr algn="ctr"/>
+            <a:r>
+              <a:rPr sz="1100" b="0">
+                <a:solidFill>
+                  <a:srgbClr val="B0B8C1"/>
+                </a:solidFill>
+                <a:latin typeface="Oswald"/>
+              </a:rPr>
+              <a:t>Terminid specialists</a:t>
             </a:r>
           </a:p>
         </p:txBody>
       </p:sp>
       <p:pic>
         <p:nvPicPr>
-          <p:cNvPr id="12" name="Picture 11" descr="3rd-kraken-division-olive.png"/>
+          <p:cNvPr id="12" name="Picture 11" descr="bear-plt-olive.png"/>
           <p:cNvPicPr>
             <a:picLocks noChangeAspect="1"/>
           </p:cNvPicPr>
@@ -3442,8 +3431,8 @@
         </p:blipFill>
         <p:spPr>
           <a:xfrm>
-            <a:off x="5136969" y="868680"/>
-            <a:ext cx="1156062" cy="1371600"/>
+            <a:off x="2862726" y="2926080"/>
+            <a:ext cx="1132549" cy="1371600"/>
           </a:xfrm>
           <a:prstGeom prst="rect">
             <a:avLst/>
@@ -3458,8 +3447,8 @@
         </p:nvSpPr>
         <p:spPr>
           <a:xfrm>
-            <a:off x="4612000" y="2286000"/>
-            <a:ext cx="2206000" cy="502920"/>
+            <a:off x="2326000" y="4343400"/>
+            <a:ext cx="2206000" cy="274320"/>
           </a:xfrm>
           <a:prstGeom prst="rect">
             <a:avLst/>
@@ -3474,32 +3463,20 @@
           <a:p>
             <a:pPr algn="ctr"/>
             <a:r>
-              <a:rPr sz="1400" b="1">
+              <a:rPr sz="1300" b="1">
                 <a:solidFill>
-                  <a:srgbClr val="A65CE6"/>
+                  <a:srgbClr val="FFFFFF"/>
                 </a:solidFill>
                 <a:latin typeface="Oswald"/>
               </a:rPr>
-              <a:t>3rd Kraken Division</a:t>
-            </a:r>
-          </a:p>
-          <a:p>
-            <a:pPr algn="ctr"/>
-            <a:r>
-              <a:rPr sz="1100" b="0">
-                <a:solidFill>
-                  <a:srgbClr val="B0B8C1"/>
-                </a:solidFill>
-                <a:latin typeface="Oswald"/>
-              </a:rPr>
-              <a:t>Illuminate specialists</a:t>
+              <a:t>BEAR PLT</a:t>
             </a:r>
           </a:p>
         </p:txBody>
       </p:sp>
       <p:pic>
         <p:nvPicPr>
-          <p:cNvPr id="14" name="Picture 13" descr="fox-coy-olive.png"/>
+          <p:cNvPr id="14" name="Picture 13" descr="3rd-kraken-division-olive.png"/>
           <p:cNvPicPr>
             <a:picLocks noChangeAspect="1"/>
           </p:cNvPicPr>
@@ -3513,8 +3490,8 @@
         </p:blipFill>
         <p:spPr>
           <a:xfrm>
-            <a:off x="5148726" y="2926080"/>
-            <a:ext cx="1132549" cy="1371600"/>
+            <a:off x="5136969" y="868680"/>
+            <a:ext cx="1156062" cy="1371600"/>
           </a:xfrm>
           <a:prstGeom prst="rect">
             <a:avLst/>
@@ -3529,8 +3506,8 @@
         </p:nvSpPr>
         <p:spPr>
           <a:xfrm>
-            <a:off x="4612000" y="4343400"/>
-            <a:ext cx="2206000" cy="274320"/>
+            <a:off x="4612000" y="2286000"/>
+            <a:ext cx="2206000" cy="502920"/>
           </a:xfrm>
           <a:prstGeom prst="rect">
             <a:avLst/>
@@ -3545,20 +3522,32 @@
           <a:p>
             <a:pPr algn="ctr"/>
             <a:r>
-              <a:rPr sz="1300" b="1">
+              <a:rPr sz="1400" b="1">
                 <a:solidFill>
-                  <a:srgbClr val="FFFFFF"/>
+                  <a:srgbClr val="A65CE6"/>
                 </a:solidFill>
                 <a:latin typeface="Oswald"/>
               </a:rPr>
-              <a:t>FOX Coy</a:t>
+              <a:t>3rd Kraken Division</a:t>
+            </a:r>
+          </a:p>
+          <a:p>
+            <a:pPr algn="ctr"/>
+            <a:r>
+              <a:rPr sz="1100" b="0">
+                <a:solidFill>
+                  <a:srgbClr val="B0B8C1"/>
+                </a:solidFill>
+                <a:latin typeface="Oswald"/>
+              </a:rPr>
+              <a:t>Illuminate specialists</a:t>
             </a:r>
           </a:p>
         </p:txBody>
       </p:sp>
       <p:pic>
         <p:nvPicPr>
-          <p:cNvPr id="16" name="Picture 15" descr="4th-cavalry-division-final.png"/>
+          <p:cNvPr id="16" name="Picture 15" descr="fox-plt-olive.png"/>
           <p:cNvPicPr>
             <a:picLocks noChangeAspect="1"/>
           </p:cNvPicPr>
@@ -3572,8 +3561,8 @@
         </p:blipFill>
         <p:spPr>
           <a:xfrm>
-            <a:off x="7422969" y="868680"/>
-            <a:ext cx="1156062" cy="1371600"/>
+            <a:off x="5148726" y="2926080"/>
+            <a:ext cx="1132549" cy="1371600"/>
           </a:xfrm>
           <a:prstGeom prst="rect">
             <a:avLst/>
@@ -3588,8 +3577,8 @@
         </p:nvSpPr>
         <p:spPr>
           <a:xfrm>
-            <a:off x="6898000" y="2286000"/>
-            <a:ext cx="2206000" cy="502920"/>
+            <a:off x="4612000" y="4343400"/>
+            <a:ext cx="2206000" cy="274320"/>
           </a:xfrm>
           <a:prstGeom prst="rect">
             <a:avLst/>
@@ -3604,32 +3593,20 @@
           <a:p>
             <a:pPr algn="ctr"/>
             <a:r>
-              <a:rPr sz="1400" b="1">
+              <a:rPr sz="1300" b="1">
                 <a:solidFill>
-                  <a:srgbClr val="60A040"/>
+                  <a:srgbClr val="FFFFFF"/>
                 </a:solidFill>
                 <a:latin typeface="Oswald"/>
               </a:rPr>
-              <a:t>4th Cavalry Division</a:t>
-            </a:r>
-          </a:p>
-          <a:p>
-            <a:pPr algn="ctr"/>
-            <a:r>
-              <a:rPr sz="1100" b="0">
-                <a:solidFill>
-                  <a:srgbClr val="B0B8C1"/>
-                </a:solidFill>
-                <a:latin typeface="Oswald"/>
-              </a:rPr>
-              <a:t>Vehicle specialists</a:t>
+              <a:t>FOX PLT</a:t>
             </a:r>
           </a:p>
         </p:txBody>
       </p:sp>
       <p:pic>
         <p:nvPicPr>
-          <p:cNvPr id="18" name="Picture 17" descr="bronco-coy-olive.png"/>
+          <p:cNvPr id="18" name="Picture 17" descr="4th-cavalry-division-final.png"/>
           <p:cNvPicPr>
             <a:picLocks noChangeAspect="1"/>
           </p:cNvPicPr>
@@ -3643,8 +3620,8 @@
         </p:blipFill>
         <p:spPr>
           <a:xfrm>
-            <a:off x="7433746" y="2926080"/>
-            <a:ext cx="1134509" cy="1371600"/>
+            <a:off x="7422969" y="868680"/>
+            <a:ext cx="1156062" cy="1371600"/>
           </a:xfrm>
           <a:prstGeom prst="rect">
             <a:avLst/>
@@ -3654,6 +3631,77 @@
       <p:sp>
         <p:nvSpPr>
           <p:cNvPr id="19" name="TextBox 18"/>
+          <p:cNvSpPr txBox="1"/>
+          <p:nvPr/>
+        </p:nvSpPr>
+        <p:spPr>
+          <a:xfrm>
+            <a:off x="6898000" y="2286000"/>
+            <a:ext cx="2206000" cy="502920"/>
+          </a:xfrm>
+          <a:prstGeom prst="rect">
+            <a:avLst/>
+          </a:prstGeom>
+          <a:noFill/>
+        </p:spPr>
+        <p:txBody>
+          <a:bodyPr wrap="square">
+            <a:spAutoFit/>
+          </a:bodyPr>
+          <a:lstStyle/>
+          <a:p>
+            <a:pPr algn="ctr"/>
+            <a:r>
+              <a:rPr sz="1400" b="1">
+                <a:solidFill>
+                  <a:srgbClr val="60A040"/>
+                </a:solidFill>
+                <a:latin typeface="Oswald"/>
+              </a:rPr>
+              <a:t>4th Cavalry Division</a:t>
+            </a:r>
+          </a:p>
+          <a:p>
+            <a:pPr algn="ctr"/>
+            <a:r>
+              <a:rPr sz="1100" b="0">
+                <a:solidFill>
+                  <a:srgbClr val="B0B8C1"/>
+                </a:solidFill>
+                <a:latin typeface="Oswald"/>
+              </a:rPr>
+              <a:t>Vehicle specialists</a:t>
+            </a:r>
+          </a:p>
+        </p:txBody>
+      </p:sp>
+      <p:pic>
+        <p:nvPicPr>
+          <p:cNvPr id="20" name="Picture 19" descr="bronco-plt-olive.png"/>
+          <p:cNvPicPr>
+            <a:picLocks noChangeAspect="1"/>
+          </p:cNvPicPr>
+          <p:nvPr/>
+        </p:nvPicPr>
+        <p:blipFill>
+          <a:blip r:embed="rId10"/>
+          <a:stretch>
+            <a:fillRect/>
+          </a:stretch>
+        </p:blipFill>
+        <p:spPr>
+          <a:xfrm>
+            <a:off x="7433746" y="2926080"/>
+            <a:ext cx="1134509" cy="1371600"/>
+          </a:xfrm>
+          <a:prstGeom prst="rect">
+            <a:avLst/>
+          </a:prstGeom>
+        </p:spPr>
+      </p:pic>
+      <p:sp>
+        <p:nvSpPr>
+          <p:cNvPr id="21" name="TextBox 20"/>
           <p:cNvSpPr txBox="1"/>
           <p:nvPr/>
         </p:nvSpPr>
@@ -3681,14 +3729,14 @@
                 </a:solidFill>
                 <a:latin typeface="Oswald"/>
               </a:rPr>
-              <a:t>BRONCO Coy</a:t>
-            </a:r>
-          </a:p>
-        </p:txBody>
-      </p:sp>
-      <p:sp>
-        <p:nvSpPr>
-          <p:cNvPr id="20" name="TextBox 19"/>
+              <a:t>BRONCO PLT</a:t>
+            </a:r>
+          </a:p>
+        </p:txBody>
+      </p:sp>
+      <p:sp>
+        <p:nvSpPr>
+          <p:cNvPr id="22" name="TextBox 21"/>
           <p:cNvSpPr txBox="1"/>
           <p:nvPr/>
         </p:nvSpPr>

</xml_diff>

<commit_message>
Restructure: three divisions, five platoons (Recon, Mechanized, Riot, Grenadier, Jump); division patches; retire 4th Cavalry and old platoon patches
</commit_message>
<xml_diff>
--- a/structure/101st-structure.pptx
+++ b/structure/101st-structure.pptx
@@ -3209,7 +3209,7 @@
                 </a:solidFill>
                 <a:latin typeface="Oswald"/>
               </a:rPr>
-              <a:t>Four divisions: one for each enemy faction, plus the Cavalry on vehicles.</a:t>
+              <a:t>Three divisions: one for each enemy faction.</a:t>
             </a:r>
           </a:p>
         </p:txBody>
@@ -3230,8 +3230,8 @@
         </p:blipFill>
         <p:spPr>
           <a:xfrm>
-            <a:off x="564969" y="868680"/>
-            <a:ext cx="1156062" cy="1371600"/>
+            <a:off x="868898" y="868680"/>
+            <a:ext cx="1310204" cy="1554480"/>
           </a:xfrm>
           <a:prstGeom prst="rect">
             <a:avLst/>
@@ -3246,8 +3246,8 @@
         </p:nvSpPr>
         <p:spPr>
           <a:xfrm>
-            <a:off x="40000" y="2286000"/>
-            <a:ext cx="2206000" cy="502920"/>
+            <a:off x="60000" y="2468880"/>
+            <a:ext cx="2928000" cy="502920"/>
           </a:xfrm>
           <a:prstGeom prst="rect">
             <a:avLst/>
@@ -3262,7 +3262,7 @@
           <a:p>
             <a:pPr algn="ctr"/>
             <a:r>
-              <a:rPr sz="1400" b="1">
+              <a:rPr sz="1500" b="1">
                 <a:solidFill>
                   <a:srgbClr val="FF0000"/>
                 </a:solidFill>
@@ -3285,9 +3285,117 @@
           </a:p>
         </p:txBody>
       </p:sp>
+      <p:sp>
+        <p:nvSpPr>
+          <p:cNvPr id="8" name="Rounded Rectangle 7"/>
+          <p:cNvSpPr/>
+          <p:nvPr/>
+        </p:nvSpPr>
+        <p:spPr>
+          <a:xfrm>
+            <a:off x="426720" y="3154680"/>
+            <a:ext cx="2194560" cy="411480"/>
+          </a:xfrm>
+          <a:prstGeom prst="roundRect">
+            <a:avLst/>
+          </a:prstGeom>
+          <a:solidFill>
+            <a:srgbClr val="5A6B2E"/>
+          </a:solidFill>
+          <a:ln w="28575">
+            <a:solidFill>
+              <a:srgbClr val="FF0000"/>
+            </a:solidFill>
+          </a:ln>
+        </p:spPr>
+        <p:style>
+          <a:lnRef idx="1">
+            <a:schemeClr val="accent1"/>
+          </a:lnRef>
+          <a:fillRef idx="3">
+            <a:schemeClr val="accent1"/>
+          </a:fillRef>
+          <a:effectRef idx="2">
+            <a:schemeClr val="accent1"/>
+          </a:effectRef>
+          <a:fontRef idx="minor">
+            <a:schemeClr val="lt1"/>
+          </a:fontRef>
+        </p:style>
+        <p:txBody>
+          <a:bodyPr rtlCol="0" anchor="ctr"/>
+          <a:lstStyle/>
+          <a:p>
+            <a:pPr algn="ctr"/>
+            <a:r>
+              <a:rPr b="1" sz="1400">
+                <a:solidFill>
+                  <a:srgbClr val="FFFFFF"/>
+                </a:solidFill>
+                <a:latin typeface="Oswald"/>
+              </a:rPr>
+              <a:t>RECON PLT</a:t>
+            </a:r>
+          </a:p>
+        </p:txBody>
+      </p:sp>
+      <p:sp>
+        <p:nvSpPr>
+          <p:cNvPr id="9" name="Rounded Rectangle 8"/>
+          <p:cNvSpPr/>
+          <p:nvPr/>
+        </p:nvSpPr>
+        <p:spPr>
+          <a:xfrm>
+            <a:off x="426720" y="3703320"/>
+            <a:ext cx="2194560" cy="411480"/>
+          </a:xfrm>
+          <a:prstGeom prst="roundRect">
+            <a:avLst/>
+          </a:prstGeom>
+          <a:solidFill>
+            <a:srgbClr val="5A6B2E"/>
+          </a:solidFill>
+          <a:ln w="28575">
+            <a:solidFill>
+              <a:srgbClr val="FF0000"/>
+            </a:solidFill>
+          </a:ln>
+        </p:spPr>
+        <p:style>
+          <a:lnRef idx="1">
+            <a:schemeClr val="accent1"/>
+          </a:lnRef>
+          <a:fillRef idx="3">
+            <a:schemeClr val="accent1"/>
+          </a:fillRef>
+          <a:effectRef idx="2">
+            <a:schemeClr val="accent1"/>
+          </a:effectRef>
+          <a:fontRef idx="minor">
+            <a:schemeClr val="lt1"/>
+          </a:fontRef>
+        </p:style>
+        <p:txBody>
+          <a:bodyPr rtlCol="0" anchor="ctr"/>
+          <a:lstStyle/>
+          <a:p>
+            <a:pPr algn="ctr"/>
+            <a:r>
+              <a:rPr b="1" sz="1400">
+                <a:solidFill>
+                  <a:srgbClr val="FFFFFF"/>
+                </a:solidFill>
+                <a:latin typeface="Oswald"/>
+              </a:rPr>
+              <a:t>MECHANIZED PLT</a:t>
+            </a:r>
+          </a:p>
+        </p:txBody>
+      </p:sp>
       <p:pic>
         <p:nvPicPr>
-          <p:cNvPr id="8" name="Picture 7" descr="eagle-plt-olive.png"/>
+          <p:cNvPr id="10" name="Picture 9" descr="2nd-scorpion-division-olive.png"/>
           <p:cNvPicPr>
             <a:picLocks noChangeAspect="1"/>
           </p:cNvPicPr>
@@ -3301,8 +3409,8 @@
         </p:blipFill>
         <p:spPr>
           <a:xfrm>
-            <a:off x="576726" y="2926080"/>
-            <a:ext cx="1132549" cy="1371600"/>
+            <a:off x="3916898" y="868680"/>
+            <a:ext cx="1310204" cy="1554480"/>
           </a:xfrm>
           <a:prstGeom prst="rect">
             <a:avLst/>
@@ -3311,14 +3419,14 @@
       </p:pic>
       <p:sp>
         <p:nvSpPr>
-          <p:cNvPr id="9" name="TextBox 8"/>
+          <p:cNvPr id="11" name="TextBox 10"/>
           <p:cNvSpPr txBox="1"/>
           <p:nvPr/>
         </p:nvSpPr>
         <p:spPr>
           <a:xfrm>
-            <a:off x="40000" y="4343400"/>
-            <a:ext cx="2206000" cy="274320"/>
+            <a:off x="3108000" y="2468880"/>
+            <a:ext cx="2928000" cy="502920"/>
           </a:xfrm>
           <a:prstGeom prst="rect">
             <a:avLst/>
@@ -3333,20 +3441,140 @@
           <a:p>
             <a:pPr algn="ctr"/>
             <a:r>
-              <a:rPr sz="1300" b="1">
+              <a:rPr sz="1500" b="1">
+                <a:solidFill>
+                  <a:srgbClr val="C7D154"/>
+                </a:solidFill>
+                <a:latin typeface="Oswald"/>
+              </a:rPr>
+              <a:t>2nd Scorpion Division</a:t>
+            </a:r>
+          </a:p>
+          <a:p>
+            <a:pPr algn="ctr"/>
+            <a:r>
+              <a:rPr sz="1100" b="0">
+                <a:solidFill>
+                  <a:srgbClr val="B0B8C1"/>
+                </a:solidFill>
+                <a:latin typeface="Oswald"/>
+              </a:rPr>
+              <a:t>Terminid specialists</a:t>
+            </a:r>
+          </a:p>
+        </p:txBody>
+      </p:sp>
+      <p:sp>
+        <p:nvSpPr>
+          <p:cNvPr id="12" name="Rounded Rectangle 11"/>
+          <p:cNvSpPr/>
+          <p:nvPr/>
+        </p:nvSpPr>
+        <p:spPr>
+          <a:xfrm>
+            <a:off x="3474720" y="3154680"/>
+            <a:ext cx="2194560" cy="411480"/>
+          </a:xfrm>
+          <a:prstGeom prst="roundRect">
+            <a:avLst/>
+          </a:prstGeom>
+          <a:solidFill>
+            <a:srgbClr val="5A6B2E"/>
+          </a:solidFill>
+          <a:ln w="28575">
+            <a:solidFill>
+              <a:srgbClr val="C7D154"/>
+            </a:solidFill>
+          </a:ln>
+        </p:spPr>
+        <p:style>
+          <a:lnRef idx="1">
+            <a:schemeClr val="accent1"/>
+          </a:lnRef>
+          <a:fillRef idx="3">
+            <a:schemeClr val="accent1"/>
+          </a:fillRef>
+          <a:effectRef idx="2">
+            <a:schemeClr val="accent1"/>
+          </a:effectRef>
+          <a:fontRef idx="minor">
+            <a:schemeClr val="lt1"/>
+          </a:fontRef>
+        </p:style>
+        <p:txBody>
+          <a:bodyPr rtlCol="0" anchor="ctr"/>
+          <a:lstStyle/>
+          <a:p>
+            <a:pPr algn="ctr"/>
+            <a:r>
+              <a:rPr b="1" sz="1400">
                 <a:solidFill>
                   <a:srgbClr val="FFFFFF"/>
                 </a:solidFill>
                 <a:latin typeface="Oswald"/>
               </a:rPr>
-              <a:t>EAGLE PLT</a:t>
+              <a:t>RIOT PLT</a:t>
+            </a:r>
+          </a:p>
+        </p:txBody>
+      </p:sp>
+      <p:sp>
+        <p:nvSpPr>
+          <p:cNvPr id="13" name="Rounded Rectangle 12"/>
+          <p:cNvSpPr/>
+          <p:nvPr/>
+        </p:nvSpPr>
+        <p:spPr>
+          <a:xfrm>
+            <a:off x="3474720" y="3703320"/>
+            <a:ext cx="2194560" cy="411480"/>
+          </a:xfrm>
+          <a:prstGeom prst="roundRect">
+            <a:avLst/>
+          </a:prstGeom>
+          <a:solidFill>
+            <a:srgbClr val="5A6B2E"/>
+          </a:solidFill>
+          <a:ln w="28575">
+            <a:solidFill>
+              <a:srgbClr val="C7D154"/>
+            </a:solidFill>
+          </a:ln>
+        </p:spPr>
+        <p:style>
+          <a:lnRef idx="1">
+            <a:schemeClr val="accent1"/>
+          </a:lnRef>
+          <a:fillRef idx="3">
+            <a:schemeClr val="accent1"/>
+          </a:fillRef>
+          <a:effectRef idx="2">
+            <a:schemeClr val="accent1"/>
+          </a:effectRef>
+          <a:fontRef idx="minor">
+            <a:schemeClr val="lt1"/>
+          </a:fontRef>
+        </p:style>
+        <p:txBody>
+          <a:bodyPr rtlCol="0" anchor="ctr"/>
+          <a:lstStyle/>
+          <a:p>
+            <a:pPr algn="ctr"/>
+            <a:r>
+              <a:rPr b="1" sz="1400">
+                <a:solidFill>
+                  <a:srgbClr val="FFFFFF"/>
+                </a:solidFill>
+                <a:latin typeface="Oswald"/>
+              </a:rPr>
+              <a:t>GRENADIER PLT</a:t>
             </a:r>
           </a:p>
         </p:txBody>
       </p:sp>
       <p:pic>
         <p:nvPicPr>
-          <p:cNvPr id="10" name="Picture 9" descr="2nd-scorpion-division-olive.png"/>
+          <p:cNvPr id="14" name="Picture 13" descr="3rd-kraken-division-olive.png"/>
           <p:cNvPicPr>
             <a:picLocks noChangeAspect="1"/>
           </p:cNvPicPr>
@@ -3360,8 +3588,8 @@
         </p:blipFill>
         <p:spPr>
           <a:xfrm>
-            <a:off x="2850969" y="868680"/>
-            <a:ext cx="1156062" cy="1371600"/>
+            <a:off x="6964898" y="868680"/>
+            <a:ext cx="1310204" cy="1554480"/>
           </a:xfrm>
           <a:prstGeom prst="rect">
             <a:avLst/>
@@ -3370,14 +3598,14 @@
       </p:pic>
       <p:sp>
         <p:nvSpPr>
-          <p:cNvPr id="11" name="TextBox 10"/>
+          <p:cNvPr id="15" name="TextBox 14"/>
           <p:cNvSpPr txBox="1"/>
           <p:nvPr/>
         </p:nvSpPr>
         <p:spPr>
           <a:xfrm>
-            <a:off x="2326000" y="2286000"/>
-            <a:ext cx="2206000" cy="502920"/>
+            <a:off x="6156000" y="2468880"/>
+            <a:ext cx="2928000" cy="502920"/>
           </a:xfrm>
           <a:prstGeom prst="rect">
             <a:avLst/>
@@ -3392,137 +3620,7 @@
           <a:p>
             <a:pPr algn="ctr"/>
             <a:r>
-              <a:rPr sz="1400" b="1">
-                <a:solidFill>
-                  <a:srgbClr val="C7D154"/>
-                </a:solidFill>
-                <a:latin typeface="Oswald"/>
-              </a:rPr>
-              <a:t>2nd Scorpion Division</a:t>
-            </a:r>
-          </a:p>
-          <a:p>
-            <a:pPr algn="ctr"/>
-            <a:r>
-              <a:rPr sz="1100" b="0">
-                <a:solidFill>
-                  <a:srgbClr val="B0B8C1"/>
-                </a:solidFill>
-                <a:latin typeface="Oswald"/>
-              </a:rPr>
-              <a:t>Terminid specialists</a:t>
-            </a:r>
-          </a:p>
-        </p:txBody>
-      </p:sp>
-      <p:pic>
-        <p:nvPicPr>
-          <p:cNvPr id="12" name="Picture 11" descr="bear-plt-olive.png"/>
-          <p:cNvPicPr>
-            <a:picLocks noChangeAspect="1"/>
-          </p:cNvPicPr>
-          <p:nvPr/>
-        </p:nvPicPr>
-        <p:blipFill>
-          <a:blip r:embed="rId6"/>
-          <a:stretch>
-            <a:fillRect/>
-          </a:stretch>
-        </p:blipFill>
-        <p:spPr>
-          <a:xfrm>
-            <a:off x="2862726" y="2926080"/>
-            <a:ext cx="1132549" cy="1371600"/>
-          </a:xfrm>
-          <a:prstGeom prst="rect">
-            <a:avLst/>
-          </a:prstGeom>
-        </p:spPr>
-      </p:pic>
-      <p:sp>
-        <p:nvSpPr>
-          <p:cNvPr id="13" name="TextBox 12"/>
-          <p:cNvSpPr txBox="1"/>
-          <p:nvPr/>
-        </p:nvSpPr>
-        <p:spPr>
-          <a:xfrm>
-            <a:off x="2326000" y="4343400"/>
-            <a:ext cx="2206000" cy="274320"/>
-          </a:xfrm>
-          <a:prstGeom prst="rect">
-            <a:avLst/>
-          </a:prstGeom>
-          <a:noFill/>
-        </p:spPr>
-        <p:txBody>
-          <a:bodyPr wrap="square">
-            <a:spAutoFit/>
-          </a:bodyPr>
-          <a:lstStyle/>
-          <a:p>
-            <a:pPr algn="ctr"/>
-            <a:r>
-              <a:rPr sz="1300" b="1">
-                <a:solidFill>
-                  <a:srgbClr val="FFFFFF"/>
-                </a:solidFill>
-                <a:latin typeface="Oswald"/>
-              </a:rPr>
-              <a:t>BEAR PLT</a:t>
-            </a:r>
-          </a:p>
-        </p:txBody>
-      </p:sp>
-      <p:pic>
-        <p:nvPicPr>
-          <p:cNvPr id="14" name="Picture 13" descr="3rd-kraken-division-olive.png"/>
-          <p:cNvPicPr>
-            <a:picLocks noChangeAspect="1"/>
-          </p:cNvPicPr>
-          <p:nvPr/>
-        </p:nvPicPr>
-        <p:blipFill>
-          <a:blip r:embed="rId7"/>
-          <a:stretch>
-            <a:fillRect/>
-          </a:stretch>
-        </p:blipFill>
-        <p:spPr>
-          <a:xfrm>
-            <a:off x="5136969" y="868680"/>
-            <a:ext cx="1156062" cy="1371600"/>
-          </a:xfrm>
-          <a:prstGeom prst="rect">
-            <a:avLst/>
-          </a:prstGeom>
-        </p:spPr>
-      </p:pic>
-      <p:sp>
-        <p:nvSpPr>
-          <p:cNvPr id="15" name="TextBox 14"/>
-          <p:cNvSpPr txBox="1"/>
-          <p:nvPr/>
-        </p:nvSpPr>
-        <p:spPr>
-          <a:xfrm>
-            <a:off x="4612000" y="2286000"/>
-            <a:ext cx="2206000" cy="502920"/>
-          </a:xfrm>
-          <a:prstGeom prst="rect">
-            <a:avLst/>
-          </a:prstGeom>
-          <a:noFill/>
-        </p:spPr>
-        <p:txBody>
-          <a:bodyPr wrap="square">
-            <a:spAutoFit/>
-          </a:bodyPr>
-          <a:lstStyle/>
-          <a:p>
-            <a:pPr algn="ctr"/>
-            <a:r>
-              <a:rPr sz="1400" b="1">
+              <a:rPr sz="1500" b="1">
                 <a:solidFill>
                   <a:srgbClr val="A65CE6"/>
                 </a:solidFill>
@@ -3545,198 +3643,63 @@
           </a:p>
         </p:txBody>
       </p:sp>
-      <p:pic>
-        <p:nvPicPr>
-          <p:cNvPr id="16" name="Picture 15" descr="fox-plt-olive.png"/>
-          <p:cNvPicPr>
-            <a:picLocks noChangeAspect="1"/>
-          </p:cNvPicPr>
+      <p:sp>
+        <p:nvSpPr>
+          <p:cNvPr id="16" name="Rounded Rectangle 15"/>
+          <p:cNvSpPr/>
           <p:nvPr/>
-        </p:nvPicPr>
-        <p:blipFill>
-          <a:blip r:embed="rId8"/>
-          <a:stretch>
-            <a:fillRect/>
-          </a:stretch>
-        </p:blipFill>
+        </p:nvSpPr>
         <p:spPr>
           <a:xfrm>
-            <a:off x="5148726" y="2926080"/>
-            <a:ext cx="1132549" cy="1371600"/>
+            <a:off x="6522720" y="3154680"/>
+            <a:ext cx="2194560" cy="411480"/>
           </a:xfrm>
-          <a:prstGeom prst="rect">
+          <a:prstGeom prst="roundRect">
             <a:avLst/>
           </a:prstGeom>
+          <a:solidFill>
+            <a:srgbClr val="5A6B2E"/>
+          </a:solidFill>
+          <a:ln w="28575">
+            <a:solidFill>
+              <a:srgbClr val="A65CE6"/>
+            </a:solidFill>
+          </a:ln>
         </p:spPr>
-      </p:pic>
-      <p:sp>
-        <p:nvSpPr>
-          <p:cNvPr id="17" name="TextBox 16"/>
-          <p:cNvSpPr txBox="1"/>
-          <p:nvPr/>
-        </p:nvSpPr>
-        <p:spPr>
-          <a:xfrm>
-            <a:off x="4612000" y="4343400"/>
-            <a:ext cx="2206000" cy="274320"/>
-          </a:xfrm>
-          <a:prstGeom prst="rect">
-            <a:avLst/>
-          </a:prstGeom>
-          <a:noFill/>
-        </p:spPr>
-        <p:txBody>
-          <a:bodyPr wrap="square">
-            <a:spAutoFit/>
-          </a:bodyPr>
+        <p:style>
+          <a:lnRef idx="1">
+            <a:schemeClr val="accent1"/>
+          </a:lnRef>
+          <a:fillRef idx="3">
+            <a:schemeClr val="accent1"/>
+          </a:fillRef>
+          <a:effectRef idx="2">
+            <a:schemeClr val="accent1"/>
+          </a:effectRef>
+          <a:fontRef idx="minor">
+            <a:schemeClr val="lt1"/>
+          </a:fontRef>
+        </p:style>
+        <p:txBody>
+          <a:bodyPr rtlCol="0" anchor="ctr"/>
           <a:lstStyle/>
           <a:p>
             <a:pPr algn="ctr"/>
             <a:r>
-              <a:rPr sz="1300" b="1">
+              <a:rPr b="1" sz="1400">
                 <a:solidFill>
                   <a:srgbClr val="FFFFFF"/>
                 </a:solidFill>
                 <a:latin typeface="Oswald"/>
               </a:rPr>
-              <a:t>FOX PLT</a:t>
-            </a:r>
-          </a:p>
-        </p:txBody>
-      </p:sp>
-      <p:pic>
-        <p:nvPicPr>
-          <p:cNvPr id="18" name="Picture 17" descr="4th-cavalry-division-final.png"/>
-          <p:cNvPicPr>
-            <a:picLocks noChangeAspect="1"/>
-          </p:cNvPicPr>
-          <p:nvPr/>
-        </p:nvPicPr>
-        <p:blipFill>
-          <a:blip r:embed="rId9"/>
-          <a:stretch>
-            <a:fillRect/>
-          </a:stretch>
-        </p:blipFill>
-        <p:spPr>
-          <a:xfrm>
-            <a:off x="7422969" y="868680"/>
-            <a:ext cx="1156062" cy="1371600"/>
-          </a:xfrm>
-          <a:prstGeom prst="rect">
-            <a:avLst/>
-          </a:prstGeom>
-        </p:spPr>
-      </p:pic>
-      <p:sp>
-        <p:nvSpPr>
-          <p:cNvPr id="19" name="TextBox 18"/>
-          <p:cNvSpPr txBox="1"/>
-          <p:nvPr/>
-        </p:nvSpPr>
-        <p:spPr>
-          <a:xfrm>
-            <a:off x="6898000" y="2286000"/>
-            <a:ext cx="2206000" cy="502920"/>
-          </a:xfrm>
-          <a:prstGeom prst="rect">
-            <a:avLst/>
-          </a:prstGeom>
-          <a:noFill/>
-        </p:spPr>
-        <p:txBody>
-          <a:bodyPr wrap="square">
-            <a:spAutoFit/>
-          </a:bodyPr>
-          <a:lstStyle/>
-          <a:p>
-            <a:pPr algn="ctr"/>
-            <a:r>
-              <a:rPr sz="1400" b="1">
-                <a:solidFill>
-                  <a:srgbClr val="60A040"/>
-                </a:solidFill>
-                <a:latin typeface="Oswald"/>
-              </a:rPr>
-              <a:t>4th Cavalry Division</a:t>
-            </a:r>
-          </a:p>
-          <a:p>
-            <a:pPr algn="ctr"/>
-            <a:r>
-              <a:rPr sz="1100" b="0">
-                <a:solidFill>
-                  <a:srgbClr val="B0B8C1"/>
-                </a:solidFill>
-                <a:latin typeface="Oswald"/>
-              </a:rPr>
-              <a:t>Vehicle specialists</a:t>
-            </a:r>
-          </a:p>
-        </p:txBody>
-      </p:sp>
-      <p:pic>
-        <p:nvPicPr>
-          <p:cNvPr id="20" name="Picture 19" descr="bronco-plt-olive.png"/>
-          <p:cNvPicPr>
-            <a:picLocks noChangeAspect="1"/>
-          </p:cNvPicPr>
-          <p:nvPr/>
-        </p:nvPicPr>
-        <p:blipFill>
-          <a:blip r:embed="rId10"/>
-          <a:stretch>
-            <a:fillRect/>
-          </a:stretch>
-        </p:blipFill>
-        <p:spPr>
-          <a:xfrm>
-            <a:off x="7433746" y="2926080"/>
-            <a:ext cx="1134509" cy="1371600"/>
-          </a:xfrm>
-          <a:prstGeom prst="rect">
-            <a:avLst/>
-          </a:prstGeom>
-        </p:spPr>
-      </p:pic>
-      <p:sp>
-        <p:nvSpPr>
-          <p:cNvPr id="21" name="TextBox 20"/>
-          <p:cNvSpPr txBox="1"/>
-          <p:nvPr/>
-        </p:nvSpPr>
-        <p:spPr>
-          <a:xfrm>
-            <a:off x="6898000" y="4343400"/>
-            <a:ext cx="2206000" cy="274320"/>
-          </a:xfrm>
-          <a:prstGeom prst="rect">
-            <a:avLst/>
-          </a:prstGeom>
-          <a:noFill/>
-        </p:spPr>
-        <p:txBody>
-          <a:bodyPr wrap="square">
-            <a:spAutoFit/>
-          </a:bodyPr>
-          <a:lstStyle/>
-          <a:p>
-            <a:pPr algn="ctr"/>
-            <a:r>
-              <a:rPr sz="1300" b="1">
-                <a:solidFill>
-                  <a:srgbClr val="FFFFFF"/>
-                </a:solidFill>
-                <a:latin typeface="Oswald"/>
-              </a:rPr>
-              <a:t>BRONCO PLT</a:t>
-            </a:r>
-          </a:p>
-        </p:txBody>
-      </p:sp>
-      <p:sp>
-        <p:nvSpPr>
-          <p:cNvPr id="22" name="TextBox 21"/>
+              <a:t>JUMP PLT</a:t>
+            </a:r>
+          </a:p>
+        </p:txBody>
+      </p:sp>
+      <p:sp>
+        <p:nvSpPr>
+          <p:cNvPr id="17" name="TextBox 16"/>
           <p:cNvSpPr txBox="1"/>
           <p:nvPr/>
         </p:nvSpPr>
@@ -3764,7 +3727,7 @@
                 </a:solidFill>
                 <a:latin typeface="Oswald"/>
               </a:rPr>
-              <a:t>Four divisions. One battalion. Every front covered.</a:t>
+              <a:t>Three divisions. One battalion. Every front covered.</a:t>
             </a:r>
           </a:p>
         </p:txBody>

</xml_diff>

<commit_message>
Rename divisions to 1st/2nd/3rd Commando Division; re-render structure chart; latest deck and PDF
</commit_message>
<xml_diff>
--- a/structure/101st-structure.pptx
+++ b/structure/101st-structure.pptx
@@ -3268,7 +3268,7 @@
                 </a:solidFill>
                 <a:latin typeface="Oswald"/>
               </a:rPr>
-              <a:t>1st Terminator Division</a:t>
+              <a:t>1st Commando Division</a:t>
             </a:r>
           </a:p>
           <a:p>
@@ -3447,7 +3447,7 @@
                 </a:solidFill>
                 <a:latin typeface="Oswald"/>
               </a:rPr>
-              <a:t>2nd Scorpion Division</a:t>
+              <a:t>2nd Commando Division</a:t>
             </a:r>
           </a:p>
           <a:p>
@@ -3626,7 +3626,7 @@
                 </a:solidFill>
                 <a:latin typeface="Oswald"/>
               </a:rPr>
-              <a:t>3rd Kraken Division</a:t>
+              <a:t>3rd Commando Division</a:t>
             </a:r>
           </a:p>
           <a:p>

</xml_diff>

<commit_message>
Structure deck and PDF with platoon patches
</commit_message>
<xml_diff>
--- a/structure/101st-structure.pptx
+++ b/structure/101st-structure.pptx
@@ -3285,117 +3285,9 @@
           </a:p>
         </p:txBody>
       </p:sp>
-      <p:sp>
-        <p:nvSpPr>
-          <p:cNvPr id="8" name="Rounded Rectangle 7"/>
-          <p:cNvSpPr/>
-          <p:nvPr/>
-        </p:nvSpPr>
-        <p:spPr>
-          <a:xfrm>
-            <a:off x="426720" y="3154680"/>
-            <a:ext cx="2194560" cy="411480"/>
-          </a:xfrm>
-          <a:prstGeom prst="roundRect">
-            <a:avLst/>
-          </a:prstGeom>
-          <a:solidFill>
-            <a:srgbClr val="5A6B2E"/>
-          </a:solidFill>
-          <a:ln w="28575">
-            <a:solidFill>
-              <a:srgbClr val="FF0000"/>
-            </a:solidFill>
-          </a:ln>
-        </p:spPr>
-        <p:style>
-          <a:lnRef idx="1">
-            <a:schemeClr val="accent1"/>
-          </a:lnRef>
-          <a:fillRef idx="3">
-            <a:schemeClr val="accent1"/>
-          </a:fillRef>
-          <a:effectRef idx="2">
-            <a:schemeClr val="accent1"/>
-          </a:effectRef>
-          <a:fontRef idx="minor">
-            <a:schemeClr val="lt1"/>
-          </a:fontRef>
-        </p:style>
-        <p:txBody>
-          <a:bodyPr rtlCol="0" anchor="ctr"/>
-          <a:lstStyle/>
-          <a:p>
-            <a:pPr algn="ctr"/>
-            <a:r>
-              <a:rPr b="1" sz="1400">
-                <a:solidFill>
-                  <a:srgbClr val="FFFFFF"/>
-                </a:solidFill>
-                <a:latin typeface="Oswald"/>
-              </a:rPr>
-              <a:t>RECON PLT</a:t>
-            </a:r>
-          </a:p>
-        </p:txBody>
-      </p:sp>
-      <p:sp>
-        <p:nvSpPr>
-          <p:cNvPr id="9" name="Rounded Rectangle 8"/>
-          <p:cNvSpPr/>
-          <p:nvPr/>
-        </p:nvSpPr>
-        <p:spPr>
-          <a:xfrm>
-            <a:off x="426720" y="3703320"/>
-            <a:ext cx="2194560" cy="411480"/>
-          </a:xfrm>
-          <a:prstGeom prst="roundRect">
-            <a:avLst/>
-          </a:prstGeom>
-          <a:solidFill>
-            <a:srgbClr val="5A6B2E"/>
-          </a:solidFill>
-          <a:ln w="28575">
-            <a:solidFill>
-              <a:srgbClr val="FF0000"/>
-            </a:solidFill>
-          </a:ln>
-        </p:spPr>
-        <p:style>
-          <a:lnRef idx="1">
-            <a:schemeClr val="accent1"/>
-          </a:lnRef>
-          <a:fillRef idx="3">
-            <a:schemeClr val="accent1"/>
-          </a:fillRef>
-          <a:effectRef idx="2">
-            <a:schemeClr val="accent1"/>
-          </a:effectRef>
-          <a:fontRef idx="minor">
-            <a:schemeClr val="lt1"/>
-          </a:fontRef>
-        </p:style>
-        <p:txBody>
-          <a:bodyPr rtlCol="0" anchor="ctr"/>
-          <a:lstStyle/>
-          <a:p>
-            <a:pPr algn="ctr"/>
-            <a:r>
-              <a:rPr b="1" sz="1400">
-                <a:solidFill>
-                  <a:srgbClr val="FFFFFF"/>
-                </a:solidFill>
-                <a:latin typeface="Oswald"/>
-              </a:rPr>
-              <a:t>MECHANIZED PLT</a:t>
-            </a:r>
-          </a:p>
-        </p:txBody>
-      </p:sp>
       <p:pic>
         <p:nvPicPr>
-          <p:cNvPr id="10" name="Picture 9" descr="2nd-scorpion-division-olive.png"/>
+          <p:cNvPr id="8" name="Picture 7" descr="recon-plt.png"/>
           <p:cNvPicPr>
             <a:picLocks noChangeAspect="1"/>
           </p:cNvPicPr>
@@ -3409,8 +3301,8 @@
         </p:blipFill>
         <p:spPr>
           <a:xfrm>
-            <a:off x="3916898" y="868680"/>
-            <a:ext cx="1310204" cy="1554480"/>
+            <a:off x="258775" y="3017520"/>
+            <a:ext cx="1066451" cy="1188720"/>
           </a:xfrm>
           <a:prstGeom prst="rect">
             <a:avLst/>
@@ -3419,14 +3311,14 @@
       </p:pic>
       <p:sp>
         <p:nvSpPr>
-          <p:cNvPr id="11" name="TextBox 10"/>
+          <p:cNvPr id="9" name="TextBox 8"/>
           <p:cNvSpPr txBox="1"/>
           <p:nvPr/>
         </p:nvSpPr>
         <p:spPr>
           <a:xfrm>
-            <a:off x="3108000" y="2468880"/>
-            <a:ext cx="2928000" cy="502920"/>
+            <a:off x="60000" y="4251960"/>
+            <a:ext cx="1464000" cy="274320"/>
           </a:xfrm>
           <a:prstGeom prst="rect">
             <a:avLst/>
@@ -3441,140 +3333,20 @@
           <a:p>
             <a:pPr algn="ctr"/>
             <a:r>
-              <a:rPr sz="1500" b="1">
-                <a:solidFill>
-                  <a:srgbClr val="C7D154"/>
-                </a:solidFill>
-                <a:latin typeface="Oswald"/>
-              </a:rPr>
-              <a:t>2nd Commando Division</a:t>
-            </a:r>
-          </a:p>
-          <a:p>
-            <a:pPr algn="ctr"/>
-            <a:r>
-              <a:rPr sz="1100" b="0">
-                <a:solidFill>
-                  <a:srgbClr val="B0B8C1"/>
-                </a:solidFill>
-                <a:latin typeface="Oswald"/>
-              </a:rPr>
-              <a:t>Terminid specialists</a:t>
-            </a:r>
-          </a:p>
-        </p:txBody>
-      </p:sp>
-      <p:sp>
-        <p:nvSpPr>
-          <p:cNvPr id="12" name="Rounded Rectangle 11"/>
-          <p:cNvSpPr/>
-          <p:nvPr/>
-        </p:nvSpPr>
-        <p:spPr>
-          <a:xfrm>
-            <a:off x="3474720" y="3154680"/>
-            <a:ext cx="2194560" cy="411480"/>
-          </a:xfrm>
-          <a:prstGeom prst="roundRect">
-            <a:avLst/>
-          </a:prstGeom>
-          <a:solidFill>
-            <a:srgbClr val="5A6B2E"/>
-          </a:solidFill>
-          <a:ln w="28575">
-            <a:solidFill>
-              <a:srgbClr val="C7D154"/>
-            </a:solidFill>
-          </a:ln>
-        </p:spPr>
-        <p:style>
-          <a:lnRef idx="1">
-            <a:schemeClr val="accent1"/>
-          </a:lnRef>
-          <a:fillRef idx="3">
-            <a:schemeClr val="accent1"/>
-          </a:fillRef>
-          <a:effectRef idx="2">
-            <a:schemeClr val="accent1"/>
-          </a:effectRef>
-          <a:fontRef idx="minor">
-            <a:schemeClr val="lt1"/>
-          </a:fontRef>
-        </p:style>
-        <p:txBody>
-          <a:bodyPr rtlCol="0" anchor="ctr"/>
-          <a:lstStyle/>
-          <a:p>
-            <a:pPr algn="ctr"/>
-            <a:r>
-              <a:rPr b="1" sz="1400">
+              <a:rPr sz="1200" b="1">
                 <a:solidFill>
                   <a:srgbClr val="FFFFFF"/>
                 </a:solidFill>
                 <a:latin typeface="Oswald"/>
               </a:rPr>
-              <a:t>RIOT PLT</a:t>
-            </a:r>
-          </a:p>
-        </p:txBody>
-      </p:sp>
-      <p:sp>
-        <p:nvSpPr>
-          <p:cNvPr id="13" name="Rounded Rectangle 12"/>
-          <p:cNvSpPr/>
-          <p:nvPr/>
-        </p:nvSpPr>
-        <p:spPr>
-          <a:xfrm>
-            <a:off x="3474720" y="3703320"/>
-            <a:ext cx="2194560" cy="411480"/>
-          </a:xfrm>
-          <a:prstGeom prst="roundRect">
-            <a:avLst/>
-          </a:prstGeom>
-          <a:solidFill>
-            <a:srgbClr val="5A6B2E"/>
-          </a:solidFill>
-          <a:ln w="28575">
-            <a:solidFill>
-              <a:srgbClr val="C7D154"/>
-            </a:solidFill>
-          </a:ln>
-        </p:spPr>
-        <p:style>
-          <a:lnRef idx="1">
-            <a:schemeClr val="accent1"/>
-          </a:lnRef>
-          <a:fillRef idx="3">
-            <a:schemeClr val="accent1"/>
-          </a:fillRef>
-          <a:effectRef idx="2">
-            <a:schemeClr val="accent1"/>
-          </a:effectRef>
-          <a:fontRef idx="minor">
-            <a:schemeClr val="lt1"/>
-          </a:fontRef>
-        </p:style>
-        <p:txBody>
-          <a:bodyPr rtlCol="0" anchor="ctr"/>
-          <a:lstStyle/>
-          <a:p>
-            <a:pPr algn="ctr"/>
-            <a:r>
-              <a:rPr b="1" sz="1400">
-                <a:solidFill>
-                  <a:srgbClr val="FFFFFF"/>
-                </a:solidFill>
-                <a:latin typeface="Oswald"/>
-              </a:rPr>
-              <a:t>GRENADIER PLT</a:t>
+              <a:t>RECON PLT</a:t>
             </a:r>
           </a:p>
         </p:txBody>
       </p:sp>
       <p:pic>
         <p:nvPicPr>
-          <p:cNvPr id="14" name="Picture 13" descr="3rd-kraken-division-olive.png"/>
+          <p:cNvPr id="10" name="Picture 9" descr="mechanized-plt.png"/>
           <p:cNvPicPr>
             <a:picLocks noChangeAspect="1"/>
           </p:cNvPicPr>
@@ -3588,8 +3360,8 @@
         </p:blipFill>
         <p:spPr>
           <a:xfrm>
-            <a:off x="6964898" y="868680"/>
-            <a:ext cx="1310204" cy="1554480"/>
+            <a:off x="1658225" y="3017520"/>
+            <a:ext cx="1195551" cy="1188720"/>
           </a:xfrm>
           <a:prstGeom prst="rect">
             <a:avLst/>
@@ -3598,7 +3370,255 @@
       </p:pic>
       <p:sp>
         <p:nvSpPr>
+          <p:cNvPr id="11" name="TextBox 10"/>
+          <p:cNvSpPr txBox="1"/>
+          <p:nvPr/>
+        </p:nvSpPr>
+        <p:spPr>
+          <a:xfrm>
+            <a:off x="1524000" y="4251960"/>
+            <a:ext cx="1464000" cy="274320"/>
+          </a:xfrm>
+          <a:prstGeom prst="rect">
+            <a:avLst/>
+          </a:prstGeom>
+          <a:noFill/>
+        </p:spPr>
+        <p:txBody>
+          <a:bodyPr wrap="square">
+            <a:spAutoFit/>
+          </a:bodyPr>
+          <a:lstStyle/>
+          <a:p>
+            <a:pPr algn="ctr"/>
+            <a:r>
+              <a:rPr sz="1200" b="1">
+                <a:solidFill>
+                  <a:srgbClr val="FFFFFF"/>
+                </a:solidFill>
+                <a:latin typeface="Oswald"/>
+              </a:rPr>
+              <a:t>MECHANIZED PLT</a:t>
+            </a:r>
+          </a:p>
+        </p:txBody>
+      </p:sp>
+      <p:pic>
+        <p:nvPicPr>
+          <p:cNvPr id="12" name="Picture 11" descr="2nd-scorpion-division-olive.png"/>
+          <p:cNvPicPr>
+            <a:picLocks noChangeAspect="1"/>
+          </p:cNvPicPr>
+          <p:nvPr/>
+        </p:nvPicPr>
+        <p:blipFill>
+          <a:blip r:embed="rId6"/>
+          <a:stretch>
+            <a:fillRect/>
+          </a:stretch>
+        </p:blipFill>
+        <p:spPr>
+          <a:xfrm>
+            <a:off x="3916898" y="868680"/>
+            <a:ext cx="1310204" cy="1554480"/>
+          </a:xfrm>
+          <a:prstGeom prst="rect">
+            <a:avLst/>
+          </a:prstGeom>
+        </p:spPr>
+      </p:pic>
+      <p:sp>
+        <p:nvSpPr>
+          <p:cNvPr id="13" name="TextBox 12"/>
+          <p:cNvSpPr txBox="1"/>
+          <p:nvPr/>
+        </p:nvSpPr>
+        <p:spPr>
+          <a:xfrm>
+            <a:off x="3108000" y="2468880"/>
+            <a:ext cx="2928000" cy="502920"/>
+          </a:xfrm>
+          <a:prstGeom prst="rect">
+            <a:avLst/>
+          </a:prstGeom>
+          <a:noFill/>
+        </p:spPr>
+        <p:txBody>
+          <a:bodyPr wrap="square">
+            <a:spAutoFit/>
+          </a:bodyPr>
+          <a:lstStyle/>
+          <a:p>
+            <a:pPr algn="ctr"/>
+            <a:r>
+              <a:rPr sz="1500" b="1">
+                <a:solidFill>
+                  <a:srgbClr val="C7D154"/>
+                </a:solidFill>
+                <a:latin typeface="Oswald"/>
+              </a:rPr>
+              <a:t>2nd Commando Division</a:t>
+            </a:r>
+          </a:p>
+          <a:p>
+            <a:pPr algn="ctr"/>
+            <a:r>
+              <a:rPr sz="1100" b="0">
+                <a:solidFill>
+                  <a:srgbClr val="B0B8C1"/>
+                </a:solidFill>
+                <a:latin typeface="Oswald"/>
+              </a:rPr>
+              <a:t>Terminid specialists</a:t>
+            </a:r>
+          </a:p>
+        </p:txBody>
+      </p:sp>
+      <p:pic>
+        <p:nvPicPr>
+          <p:cNvPr id="14" name="Picture 13" descr="riot-plt.png"/>
+          <p:cNvPicPr>
+            <a:picLocks noChangeAspect="1"/>
+          </p:cNvPicPr>
+          <p:nvPr/>
+        </p:nvPicPr>
+        <p:blipFill>
+          <a:blip r:embed="rId7"/>
+          <a:stretch>
+            <a:fillRect/>
+          </a:stretch>
+        </p:blipFill>
+        <p:spPr>
+          <a:xfrm>
+            <a:off x="3293189" y="3017520"/>
+            <a:ext cx="1093622" cy="1188720"/>
+          </a:xfrm>
+          <a:prstGeom prst="rect">
+            <a:avLst/>
+          </a:prstGeom>
+        </p:spPr>
+      </p:pic>
+      <p:sp>
+        <p:nvSpPr>
           <p:cNvPr id="15" name="TextBox 14"/>
+          <p:cNvSpPr txBox="1"/>
+          <p:nvPr/>
+        </p:nvSpPr>
+        <p:spPr>
+          <a:xfrm>
+            <a:off x="3108000" y="4251960"/>
+            <a:ext cx="1464000" cy="274320"/>
+          </a:xfrm>
+          <a:prstGeom prst="rect">
+            <a:avLst/>
+          </a:prstGeom>
+          <a:noFill/>
+        </p:spPr>
+        <p:txBody>
+          <a:bodyPr wrap="square">
+            <a:spAutoFit/>
+          </a:bodyPr>
+          <a:lstStyle/>
+          <a:p>
+            <a:pPr algn="ctr"/>
+            <a:r>
+              <a:rPr sz="1200" b="1">
+                <a:solidFill>
+                  <a:srgbClr val="FFFFFF"/>
+                </a:solidFill>
+                <a:latin typeface="Oswald"/>
+              </a:rPr>
+              <a:t>RIOT PLT</a:t>
+            </a:r>
+          </a:p>
+        </p:txBody>
+      </p:sp>
+      <p:pic>
+        <p:nvPicPr>
+          <p:cNvPr id="16" name="Picture 15" descr="grenadier-plt.png"/>
+          <p:cNvPicPr>
+            <a:picLocks noChangeAspect="1"/>
+          </p:cNvPicPr>
+          <p:nvPr/>
+        </p:nvPicPr>
+        <p:blipFill>
+          <a:blip r:embed="rId8"/>
+          <a:stretch>
+            <a:fillRect/>
+          </a:stretch>
+        </p:blipFill>
+        <p:spPr>
+          <a:xfrm>
+            <a:off x="4732566" y="3017520"/>
+            <a:ext cx="1142869" cy="1188720"/>
+          </a:xfrm>
+          <a:prstGeom prst="rect">
+            <a:avLst/>
+          </a:prstGeom>
+        </p:spPr>
+      </p:pic>
+      <p:sp>
+        <p:nvSpPr>
+          <p:cNvPr id="17" name="TextBox 16"/>
+          <p:cNvSpPr txBox="1"/>
+          <p:nvPr/>
+        </p:nvSpPr>
+        <p:spPr>
+          <a:xfrm>
+            <a:off x="4572000" y="4251960"/>
+            <a:ext cx="1464000" cy="274320"/>
+          </a:xfrm>
+          <a:prstGeom prst="rect">
+            <a:avLst/>
+          </a:prstGeom>
+          <a:noFill/>
+        </p:spPr>
+        <p:txBody>
+          <a:bodyPr wrap="square">
+            <a:spAutoFit/>
+          </a:bodyPr>
+          <a:lstStyle/>
+          <a:p>
+            <a:pPr algn="ctr"/>
+            <a:r>
+              <a:rPr sz="1200" b="1">
+                <a:solidFill>
+                  <a:srgbClr val="FFFFFF"/>
+                </a:solidFill>
+                <a:latin typeface="Oswald"/>
+              </a:rPr>
+              <a:t>GRENADIER PLT</a:t>
+            </a:r>
+          </a:p>
+        </p:txBody>
+      </p:sp>
+      <p:pic>
+        <p:nvPicPr>
+          <p:cNvPr id="18" name="Picture 17" descr="3rd-kraken-division-olive.png"/>
+          <p:cNvPicPr>
+            <a:picLocks noChangeAspect="1"/>
+          </p:cNvPicPr>
+          <p:nvPr/>
+        </p:nvPicPr>
+        <p:blipFill>
+          <a:blip r:embed="rId9"/>
+          <a:stretch>
+            <a:fillRect/>
+          </a:stretch>
+        </p:blipFill>
+        <p:spPr>
+          <a:xfrm>
+            <a:off x="6964898" y="868680"/>
+            <a:ext cx="1310204" cy="1554480"/>
+          </a:xfrm>
+          <a:prstGeom prst="rect">
+            <a:avLst/>
+          </a:prstGeom>
+        </p:spPr>
+      </p:pic>
+      <p:sp>
+        <p:nvSpPr>
+          <p:cNvPr id="19" name="TextBox 18"/>
           <p:cNvSpPr txBox="1"/>
           <p:nvPr/>
         </p:nvSpPr>
@@ -3643,50 +3663,55 @@
           </a:p>
         </p:txBody>
       </p:sp>
-      <p:sp>
-        <p:nvSpPr>
-          <p:cNvPr id="16" name="Rounded Rectangle 15"/>
-          <p:cNvSpPr/>
+      <p:pic>
+        <p:nvPicPr>
+          <p:cNvPr id="20" name="Picture 19" descr="jump-plt.png"/>
+          <p:cNvPicPr>
+            <a:picLocks noChangeAspect="1"/>
+          </p:cNvPicPr>
           <p:nvPr/>
-        </p:nvSpPr>
-        <p:spPr>
-          <a:xfrm>
-            <a:off x="6522720" y="3154680"/>
-            <a:ext cx="2194560" cy="411480"/>
-          </a:xfrm>
-          <a:prstGeom prst="roundRect">
+        </p:nvPicPr>
+        <p:blipFill>
+          <a:blip r:embed="rId10"/>
+          <a:stretch>
+            <a:fillRect/>
+          </a:stretch>
+        </p:blipFill>
+        <p:spPr>
+          <a:xfrm>
+            <a:off x="7090171" y="3017520"/>
+            <a:ext cx="1059658" cy="1188720"/>
+          </a:xfrm>
+          <a:prstGeom prst="rect">
             <a:avLst/>
           </a:prstGeom>
-          <a:solidFill>
-            <a:srgbClr val="5A6B2E"/>
-          </a:solidFill>
-          <a:ln w="28575">
-            <a:solidFill>
-              <a:srgbClr val="A65CE6"/>
-            </a:solidFill>
-          </a:ln>
-        </p:spPr>
-        <p:style>
-          <a:lnRef idx="1">
-            <a:schemeClr val="accent1"/>
-          </a:lnRef>
-          <a:fillRef idx="3">
-            <a:schemeClr val="accent1"/>
-          </a:fillRef>
-          <a:effectRef idx="2">
-            <a:schemeClr val="accent1"/>
-          </a:effectRef>
-          <a:fontRef idx="minor">
-            <a:schemeClr val="lt1"/>
-          </a:fontRef>
-        </p:style>
-        <p:txBody>
-          <a:bodyPr rtlCol="0" anchor="ctr"/>
+        </p:spPr>
+      </p:pic>
+      <p:sp>
+        <p:nvSpPr>
+          <p:cNvPr id="21" name="TextBox 20"/>
+          <p:cNvSpPr txBox="1"/>
+          <p:nvPr/>
+        </p:nvSpPr>
+        <p:spPr>
+          <a:xfrm>
+            <a:off x="6888000" y="4251960"/>
+            <a:ext cx="1464000" cy="274320"/>
+          </a:xfrm>
+          <a:prstGeom prst="rect">
+            <a:avLst/>
+          </a:prstGeom>
+          <a:noFill/>
+        </p:spPr>
+        <p:txBody>
+          <a:bodyPr wrap="square">
+            <a:spAutoFit/>
+          </a:bodyPr>
           <a:lstStyle/>
           <a:p>
             <a:pPr algn="ctr"/>
             <a:r>
-              <a:rPr b="1" sz="1400">
+              <a:rPr sz="1200" b="1">
                 <a:solidFill>
                   <a:srgbClr val="FFFFFF"/>
                 </a:solidFill>
@@ -3699,7 +3724,7 @@
       </p:sp>
       <p:sp>
         <p:nvSpPr>
-          <p:cNvPr id="17" name="TextBox 16"/>
+          <p:cNvPr id="22" name="TextBox 21"/>
           <p:cNvSpPr txBox="1"/>
           <p:nvPr/>
         </p:nvSpPr>

</xml_diff>

<commit_message>
Grenadier patch: title-case 'Grenadier PLT.' to match other platoons; re-render chart; latest deck and PDF
</commit_message>
<xml_diff>
--- a/structure/101st-structure.pptx
+++ b/structure/101st-structure.pptx
@@ -3179,44 +3179,9 @@
           </a:prstGeom>
         </p:spPr>
       </p:pic>
-      <p:sp>
-        <p:nvSpPr>
-          <p:cNvPr id="5" name="TextBox 4"/>
-          <p:cNvSpPr txBox="1"/>
-          <p:nvPr/>
-        </p:nvSpPr>
-        <p:spPr>
-          <a:xfrm>
-            <a:off x="0" y="475488"/>
-            <a:ext cx="9144000" cy="274320"/>
-          </a:xfrm>
-          <a:prstGeom prst="rect">
-            <a:avLst/>
-          </a:prstGeom>
-          <a:noFill/>
-        </p:spPr>
-        <p:txBody>
-          <a:bodyPr wrap="square">
-            <a:spAutoFit/>
-          </a:bodyPr>
-          <a:lstStyle/>
-          <a:p>
-            <a:pPr algn="ctr"/>
-            <a:r>
-              <a:rPr sz="1200" b="0">
-                <a:solidFill>
-                  <a:srgbClr val="B0B8C1"/>
-                </a:solidFill>
-                <a:latin typeface="Oswald"/>
-              </a:rPr>
-              <a:t>Three divisions: one for each enemy faction.</a:t>
-            </a:r>
-          </a:p>
-        </p:txBody>
-      </p:sp>
       <p:pic>
         <p:nvPicPr>
-          <p:cNvPr id="6" name="Picture 5" descr="1st-terminator-division-olive.png"/>
+          <p:cNvPr id="5" name="Picture 4" descr="1st-terminator-division-olive.png"/>
           <p:cNvPicPr>
             <a:picLocks noChangeAspect="1"/>
           </p:cNvPicPr>
@@ -3240,7 +3205,7 @@
       </p:pic>
       <p:sp>
         <p:nvSpPr>
-          <p:cNvPr id="7" name="TextBox 6"/>
+          <p:cNvPr id="6" name="TextBox 5"/>
           <p:cNvSpPr txBox="1"/>
           <p:nvPr/>
         </p:nvSpPr>
@@ -3287,7 +3252,7 @@
       </p:sp>
       <p:pic>
         <p:nvPicPr>
-          <p:cNvPr id="8" name="Picture 7" descr="recon-plt.png"/>
+          <p:cNvPr id="7" name="Picture 6" descr="recon-plt.png"/>
           <p:cNvPicPr>
             <a:picLocks noChangeAspect="1"/>
           </p:cNvPicPr>
@@ -3311,7 +3276,7 @@
       </p:pic>
       <p:sp>
         <p:nvSpPr>
-          <p:cNvPr id="9" name="TextBox 8"/>
+          <p:cNvPr id="8" name="TextBox 7"/>
           <p:cNvSpPr txBox="1"/>
           <p:nvPr/>
         </p:nvSpPr>
@@ -3339,14 +3304,14 @@
                 </a:solidFill>
                 <a:latin typeface="Oswald"/>
               </a:rPr>
-              <a:t>RECON PLT</a:t>
+              <a:t>Recon PLT</a:t>
             </a:r>
           </a:p>
         </p:txBody>
       </p:sp>
       <p:pic>
         <p:nvPicPr>
-          <p:cNvPr id="10" name="Picture 9" descr="mechanized-plt.png"/>
+          <p:cNvPr id="9" name="Picture 8" descr="mechanized-plt.png"/>
           <p:cNvPicPr>
             <a:picLocks noChangeAspect="1"/>
           </p:cNvPicPr>
@@ -3370,7 +3335,7 @@
       </p:pic>
       <p:sp>
         <p:nvSpPr>
-          <p:cNvPr id="11" name="TextBox 10"/>
+          <p:cNvPr id="10" name="TextBox 9"/>
           <p:cNvSpPr txBox="1"/>
           <p:nvPr/>
         </p:nvSpPr>
@@ -3398,14 +3363,14 @@
                 </a:solidFill>
                 <a:latin typeface="Oswald"/>
               </a:rPr>
-              <a:t>MECHANIZED PLT</a:t>
+              <a:t>Mechanized PLT</a:t>
             </a:r>
           </a:p>
         </p:txBody>
       </p:sp>
       <p:pic>
         <p:nvPicPr>
-          <p:cNvPr id="12" name="Picture 11" descr="2nd-scorpion-division-olive.png"/>
+          <p:cNvPr id="11" name="Picture 10" descr="2nd-scorpion-division-olive.png"/>
           <p:cNvPicPr>
             <a:picLocks noChangeAspect="1"/>
           </p:cNvPicPr>
@@ -3429,7 +3394,7 @@
       </p:pic>
       <p:sp>
         <p:nvSpPr>
-          <p:cNvPr id="13" name="TextBox 12"/>
+          <p:cNvPr id="12" name="TextBox 11"/>
           <p:cNvSpPr txBox="1"/>
           <p:nvPr/>
         </p:nvSpPr>
@@ -3476,7 +3441,7 @@
       </p:sp>
       <p:pic>
         <p:nvPicPr>
-          <p:cNvPr id="14" name="Picture 13" descr="riot-plt.png"/>
+          <p:cNvPr id="13" name="Picture 12" descr="riot-plt.png"/>
           <p:cNvPicPr>
             <a:picLocks noChangeAspect="1"/>
           </p:cNvPicPr>
@@ -3500,7 +3465,7 @@
       </p:pic>
       <p:sp>
         <p:nvSpPr>
-          <p:cNvPr id="15" name="TextBox 14"/>
+          <p:cNvPr id="14" name="TextBox 13"/>
           <p:cNvSpPr txBox="1"/>
           <p:nvPr/>
         </p:nvSpPr>
@@ -3528,14 +3493,14 @@
                 </a:solidFill>
                 <a:latin typeface="Oswald"/>
               </a:rPr>
-              <a:t>RIOT PLT</a:t>
+              <a:t>Riot PLT</a:t>
             </a:r>
           </a:p>
         </p:txBody>
       </p:sp>
       <p:pic>
         <p:nvPicPr>
-          <p:cNvPr id="16" name="Picture 15" descr="grenadier-plt.png"/>
+          <p:cNvPr id="15" name="Picture 14" descr="grenadier-plt.png"/>
           <p:cNvPicPr>
             <a:picLocks noChangeAspect="1"/>
           </p:cNvPicPr>
@@ -3559,7 +3524,7 @@
       </p:pic>
       <p:sp>
         <p:nvSpPr>
-          <p:cNvPr id="17" name="TextBox 16"/>
+          <p:cNvPr id="16" name="TextBox 15"/>
           <p:cNvSpPr txBox="1"/>
           <p:nvPr/>
         </p:nvSpPr>
@@ -3587,14 +3552,14 @@
                 </a:solidFill>
                 <a:latin typeface="Oswald"/>
               </a:rPr>
-              <a:t>GRENADIER PLT</a:t>
+              <a:t>Grenadier PLT</a:t>
             </a:r>
           </a:p>
         </p:txBody>
       </p:sp>
       <p:pic>
         <p:nvPicPr>
-          <p:cNvPr id="18" name="Picture 17" descr="3rd-kraken-division-olive.png"/>
+          <p:cNvPr id="17" name="Picture 16" descr="3rd-kraken-division-olive.png"/>
           <p:cNvPicPr>
             <a:picLocks noChangeAspect="1"/>
           </p:cNvPicPr>
@@ -3618,7 +3583,7 @@
       </p:pic>
       <p:sp>
         <p:nvSpPr>
-          <p:cNvPr id="19" name="TextBox 18"/>
+          <p:cNvPr id="18" name="TextBox 17"/>
           <p:cNvSpPr txBox="1"/>
           <p:nvPr/>
         </p:nvSpPr>
@@ -3665,7 +3630,7 @@
       </p:sp>
       <p:pic>
         <p:nvPicPr>
-          <p:cNvPr id="20" name="Picture 19" descr="jump-plt.png"/>
+          <p:cNvPr id="19" name="Picture 18" descr="jump-plt.png"/>
           <p:cNvPicPr>
             <a:picLocks noChangeAspect="1"/>
           </p:cNvPicPr>
@@ -3689,7 +3654,7 @@
       </p:pic>
       <p:sp>
         <p:nvSpPr>
-          <p:cNvPr id="21" name="TextBox 20"/>
+          <p:cNvPr id="20" name="TextBox 19"/>
           <p:cNvSpPr txBox="1"/>
           <p:nvPr/>
         </p:nvSpPr>
@@ -3717,42 +3682,7 @@
                 </a:solidFill>
                 <a:latin typeface="Oswald"/>
               </a:rPr>
-              <a:t>JUMP PLT</a:t>
-            </a:r>
-          </a:p>
-        </p:txBody>
-      </p:sp>
-      <p:sp>
-        <p:nvSpPr>
-          <p:cNvPr id="22" name="TextBox 21"/>
-          <p:cNvSpPr txBox="1"/>
-          <p:nvPr/>
-        </p:nvSpPr>
-        <p:spPr>
-          <a:xfrm>
-            <a:off x="0" y="4709160"/>
-            <a:ext cx="9144000" cy="274320"/>
-          </a:xfrm>
-          <a:prstGeom prst="rect">
-            <a:avLst/>
-          </a:prstGeom>
-          <a:noFill/>
-        </p:spPr>
-        <p:txBody>
-          <a:bodyPr wrap="square">
-            <a:spAutoFit/>
-          </a:bodyPr>
-          <a:lstStyle/>
-          <a:p>
-            <a:pPr algn="ctr"/>
-            <a:r>
-              <a:rPr sz="1100" b="0">
-                <a:solidFill>
-                  <a:srgbClr val="B0B8C1"/>
-                </a:solidFill>
-                <a:latin typeface="Oswald"/>
-              </a:rPr>
-              <a:t>Three divisions. One battalion. Every front covered.</a:t>
+              <a:t>Jump PLT</a:t>
             </a:r>
           </a:p>
         </p:txBody>

</xml_diff>

<commit_message>
Latest structure deck and PDF
</commit_message>
<xml_diff>
--- a/structure/101st-structure.pptx
+++ b/structure/101st-structure.pptx
@@ -3266,8 +3266,8 @@
         </p:blipFill>
         <p:spPr>
           <a:xfrm>
-            <a:off x="258775" y="3017520"/>
-            <a:ext cx="1066451" cy="1188720"/>
+            <a:off x="264718" y="3017520"/>
+            <a:ext cx="1054564" cy="1188720"/>
           </a:xfrm>
           <a:prstGeom prst="rect">
             <a:avLst/>

</xml_diff>

<commit_message>
Structure deck and PDF with new division patches
</commit_message>
<xml_diff>
--- a/structure/101st-structure.pptx
+++ b/structure/101st-structure.pptx
@@ -3181,7 +3181,7 @@
       </p:pic>
       <p:pic>
         <p:nvPicPr>
-          <p:cNvPr id="5" name="Picture 4" descr="1st-terminator-division-olive.png"/>
+          <p:cNvPr id="5" name="Picture 4" descr="1st-commando-division.png"/>
           <p:cNvPicPr>
             <a:picLocks noChangeAspect="1"/>
           </p:cNvPicPr>
@@ -3195,8 +3195,8 @@
         </p:blipFill>
         <p:spPr>
           <a:xfrm>
-            <a:off x="868898" y="868680"/>
-            <a:ext cx="1310204" cy="1554480"/>
+            <a:off x="791174" y="868680"/>
+            <a:ext cx="1465652" cy="1554480"/>
           </a:xfrm>
           <a:prstGeom prst="rect">
             <a:avLst/>
@@ -3370,7 +3370,7 @@
       </p:sp>
       <p:pic>
         <p:nvPicPr>
-          <p:cNvPr id="11" name="Picture 10" descr="2nd-scorpion-division-olive.png"/>
+          <p:cNvPr id="11" name="Picture 10" descr="2nd-commando-division.png"/>
           <p:cNvPicPr>
             <a:picLocks noChangeAspect="1"/>
           </p:cNvPicPr>
@@ -3384,8 +3384,8 @@
         </p:blipFill>
         <p:spPr>
           <a:xfrm>
-            <a:off x="3916898" y="868680"/>
-            <a:ext cx="1310204" cy="1554480"/>
+            <a:off x="3839174" y="868680"/>
+            <a:ext cx="1465652" cy="1554480"/>
           </a:xfrm>
           <a:prstGeom prst="rect">
             <a:avLst/>
@@ -3559,7 +3559,7 @@
       </p:sp>
       <p:pic>
         <p:nvPicPr>
-          <p:cNvPr id="17" name="Picture 16" descr="3rd-kraken-division-olive.png"/>
+          <p:cNvPr id="17" name="Picture 16" descr="3rd-commando-division.png"/>
           <p:cNvPicPr>
             <a:picLocks noChangeAspect="1"/>
           </p:cNvPicPr>
@@ -3573,8 +3573,8 @@
         </p:blipFill>
         <p:spPr>
           <a:xfrm>
-            <a:off x="6964898" y="868680"/>
-            <a:ext cx="1310204" cy="1554480"/>
+            <a:off x="6887174" y="868680"/>
+            <a:ext cx="1465652" cy="1554480"/>
           </a:xfrm>
           <a:prstGeom prst="rect">
             <a:avLst/>

</xml_diff>